<commit_message>
MAJ PPT & PowerBI
</commit_message>
<xml_diff>
--- a/Présentation - Sécurité Routière - Final.pptx
+++ b/Présentation - Sécurité Routière - Final.pptx
@@ -5,7 +5,7 @@
     <p:sldMasterId id="2147483648" r:id="rId1"/>
   </p:sldMasterIdLst>
   <p:notesMasterIdLst>
-    <p:notesMasterId r:id="rId15"/>
+    <p:notesMasterId r:id="rId16"/>
   </p:notesMasterIdLst>
   <p:sldIdLst>
     <p:sldId id="256" r:id="rId2"/>
@@ -13,14 +13,15 @@
     <p:sldId id="270" r:id="rId4"/>
     <p:sldId id="259" r:id="rId5"/>
     <p:sldId id="272" r:id="rId6"/>
-    <p:sldId id="260" r:id="rId7"/>
-    <p:sldId id="261" r:id="rId8"/>
-    <p:sldId id="263" r:id="rId9"/>
-    <p:sldId id="265" r:id="rId10"/>
-    <p:sldId id="266" r:id="rId11"/>
-    <p:sldId id="267" r:id="rId12"/>
-    <p:sldId id="268" r:id="rId13"/>
-    <p:sldId id="269" r:id="rId14"/>
+    <p:sldId id="273" r:id="rId7"/>
+    <p:sldId id="260" r:id="rId8"/>
+    <p:sldId id="261" r:id="rId9"/>
+    <p:sldId id="263" r:id="rId10"/>
+    <p:sldId id="265" r:id="rId11"/>
+    <p:sldId id="266" r:id="rId12"/>
+    <p:sldId id="267" r:id="rId13"/>
+    <p:sldId id="268" r:id="rId14"/>
+    <p:sldId id="269" r:id="rId15"/>
   </p:sldIdLst>
   <p:sldSz cx="9144000" cy="5143500" type="screen16x9"/>
   <p:notesSz cx="5143500" cy="9144000"/>
@@ -258,10 +259,217 @@
       <p15:sldGuideLst xmlns:p15="http://schemas.microsoft.com/office/powerpoint/2012/main"/>
     </p:ext>
     <p:ext uri="GoogleSlidesCustomDataVersion2">
-      <go:slidesCustomData xmlns="" xmlns:mc="http://schemas.openxmlformats.org/markup-compatibility/2006" xmlns:mv="urn:schemas-microsoft-com:mac:vml" xmlns:c="http://schemas.openxmlformats.org/drawingml/2006/chart" xmlns:dgm="http://schemas.openxmlformats.org/drawingml/2006/diagram" xmlns:o="urn:schemas-microsoft-com:office:office" xmlns:v="urn:schemas-microsoft-com:vml" xmlns:pvml="urn:schemas-microsoft-com:office:powerpoint" xmlns:com="http://schemas.openxmlformats.org/drawingml/2006/compatibility" xmlns:p14="http://schemas.microsoft.com/office/powerpoint/2010/main" xmlns:p15="http://schemas.microsoft.com/office/powerpoint/2012/main" xmlns:ahyp="http://schemas.microsoft.com/office/drawing/2018/hyperlinkcolor" xmlns:go="http://customooxmlschemas.google.com/" r:id="rId19" roundtripDataSignature="AMtx7mhF72hTUZuHk4f7Kg/0xBqhr8A67w=="/>
+      <go:slidesCustomData xmlns:go="http://customooxmlschemas.google.com/" xmlns:ahyp="http://schemas.microsoft.com/office/drawing/2018/hyperlinkcolor" xmlns:p15="http://schemas.microsoft.com/office/powerpoint/2012/main" xmlns:p14="http://schemas.microsoft.com/office/powerpoint/2010/main" xmlns:com="http://schemas.openxmlformats.org/drawingml/2006/compatibility" xmlns:pvml="urn:schemas-microsoft-com:office:powerpoint" xmlns:v="urn:schemas-microsoft-com:vml" xmlns:o="urn:schemas-microsoft-com:office:office" xmlns:dgm="http://schemas.openxmlformats.org/drawingml/2006/diagram" xmlns:c="http://schemas.openxmlformats.org/drawingml/2006/chart" xmlns:mv="urn:schemas-microsoft-com:mac:vml" xmlns:mc="http://schemas.openxmlformats.org/markup-compatibility/2006" xmlns="" r:id="rId19" roundtripDataSignature="AMtx7mhF72hTUZuHk4f7Kg/0xBqhr8A67w=="/>
     </p:ext>
   </p:extLst>
 </p:presentation>
+</file>
+
+<file path=ppt/changesInfos/changesInfo1.xml><?xml version="1.0" encoding="utf-8"?>
+<pc:chgInfo xmlns:a="http://schemas.openxmlformats.org/drawingml/2006/main" xmlns:r="http://schemas.openxmlformats.org/officeDocument/2006/relationships" xmlns:ac="http://schemas.microsoft.com/office/drawing/2013/main/command" xmlns:pc="http://schemas.microsoft.com/office/powerpoint/2013/main/command">
+  <pc:docChgLst>
+    <pc:chgData name="Paul Merieux" userId="5067b3df0a83f218" providerId="LiveId" clId="{68BDDC16-0242-43AD-A5CF-C0C7FD622F7F}"/>
+    <pc:docChg chg="undo custSel addSld modSld sldOrd">
+      <pc:chgData name="Paul Merieux" userId="5067b3df0a83f218" providerId="LiveId" clId="{68BDDC16-0242-43AD-A5CF-C0C7FD622F7F}" dt="2026-07-06T11:02:08.881" v="84" actId="5793"/>
+      <pc:docMkLst>
+        <pc:docMk/>
+      </pc:docMkLst>
+      <pc:sldChg chg="modSp mod">
+        <pc:chgData name="Paul Merieux" userId="5067b3df0a83f218" providerId="LiveId" clId="{68BDDC16-0242-43AD-A5CF-C0C7FD622F7F}" dt="2026-07-06T10:43:56.619" v="1" actId="20577"/>
+        <pc:sldMkLst>
+          <pc:docMk/>
+          <pc:sldMk cId="0" sldId="256"/>
+        </pc:sldMkLst>
+        <pc:spChg chg="mod">
+          <ac:chgData name="Paul Merieux" userId="5067b3df0a83f218" providerId="LiveId" clId="{68BDDC16-0242-43AD-A5CF-C0C7FD622F7F}" dt="2026-07-06T10:43:56.619" v="1" actId="20577"/>
+          <ac:spMkLst>
+            <pc:docMk/>
+            <pc:sldMk cId="0" sldId="256"/>
+            <ac:spMk id="18" creationId="{00000000-0000-0000-0000-000000000000}"/>
+          </ac:spMkLst>
+        </pc:spChg>
+      </pc:sldChg>
+      <pc:sldChg chg="addSp delSp modSp mod">
+        <pc:chgData name="Paul Merieux" userId="5067b3df0a83f218" providerId="LiveId" clId="{68BDDC16-0242-43AD-A5CF-C0C7FD622F7F}" dt="2026-07-06T10:50:35.905" v="31" actId="1076"/>
+        <pc:sldMkLst>
+          <pc:docMk/>
+          <pc:sldMk cId="0" sldId="260"/>
+        </pc:sldMkLst>
+        <pc:spChg chg="add del mod">
+          <ac:chgData name="Paul Merieux" userId="5067b3df0a83f218" providerId="LiveId" clId="{68BDDC16-0242-43AD-A5CF-C0C7FD622F7F}" dt="2026-07-06T10:44:08.319" v="5" actId="478"/>
+          <ac:spMkLst>
+            <pc:docMk/>
+            <pc:sldMk cId="0" sldId="260"/>
+            <ac:spMk id="3" creationId="{E6668F71-9B07-8D07-0DDF-75A495460D8F}"/>
+          </ac:spMkLst>
+        </pc:spChg>
+        <pc:grpChg chg="del">
+          <ac:chgData name="Paul Merieux" userId="5067b3df0a83f218" providerId="LiveId" clId="{68BDDC16-0242-43AD-A5CF-C0C7FD622F7F}" dt="2026-07-06T10:50:30.784" v="28" actId="478"/>
+          <ac:grpSpMkLst>
+            <pc:docMk/>
+            <pc:sldMk cId="0" sldId="260"/>
+            <ac:grpSpMk id="131" creationId="{00000000-0000-0000-0000-000000000000}"/>
+          </ac:grpSpMkLst>
+        </pc:grpChg>
+        <pc:grpChg chg="del">
+          <ac:chgData name="Paul Merieux" userId="5067b3df0a83f218" providerId="LiveId" clId="{68BDDC16-0242-43AD-A5CF-C0C7FD622F7F}" dt="2026-07-06T10:50:05.199" v="24" actId="478"/>
+          <ac:grpSpMkLst>
+            <pc:docMk/>
+            <pc:sldMk cId="0" sldId="260"/>
+            <ac:grpSpMk id="134" creationId="{00000000-0000-0000-0000-000000000000}"/>
+          </ac:grpSpMkLst>
+        </pc:grpChg>
+        <pc:picChg chg="add mod">
+          <ac:chgData name="Paul Merieux" userId="5067b3df0a83f218" providerId="LiveId" clId="{68BDDC16-0242-43AD-A5CF-C0C7FD622F7F}" dt="2026-07-06T10:50:09.954" v="27" actId="1076"/>
+          <ac:picMkLst>
+            <pc:docMk/>
+            <pc:sldMk cId="0" sldId="260"/>
+            <ac:picMk id="5" creationId="{ADA05021-F759-0779-E17D-0E7BE5CD1C45}"/>
+          </ac:picMkLst>
+        </pc:picChg>
+        <pc:picChg chg="add mod">
+          <ac:chgData name="Paul Merieux" userId="5067b3df0a83f218" providerId="LiveId" clId="{68BDDC16-0242-43AD-A5CF-C0C7FD622F7F}" dt="2026-07-06T10:50:35.905" v="31" actId="1076"/>
+          <ac:picMkLst>
+            <pc:docMk/>
+            <pc:sldMk cId="0" sldId="260"/>
+            <ac:picMk id="7" creationId="{3B105513-1BBB-6F71-C7EC-46D668FF80D0}"/>
+          </ac:picMkLst>
+        </pc:picChg>
+      </pc:sldChg>
+      <pc:sldChg chg="modSp mod">
+        <pc:chgData name="Paul Merieux" userId="5067b3df0a83f218" providerId="LiveId" clId="{68BDDC16-0242-43AD-A5CF-C0C7FD622F7F}" dt="2026-07-06T10:57:37.318" v="32" actId="13926"/>
+        <pc:sldMkLst>
+          <pc:docMk/>
+          <pc:sldMk cId="0" sldId="263"/>
+        </pc:sldMkLst>
+        <pc:spChg chg="mod">
+          <ac:chgData name="Paul Merieux" userId="5067b3df0a83f218" providerId="LiveId" clId="{68BDDC16-0242-43AD-A5CF-C0C7FD622F7F}" dt="2026-07-06T10:57:37.318" v="32" actId="13926"/>
+          <ac:spMkLst>
+            <pc:docMk/>
+            <pc:sldMk cId="0" sldId="263"/>
+            <ac:spMk id="223" creationId="{00000000-0000-0000-0000-000000000000}"/>
+          </ac:spMkLst>
+        </pc:spChg>
+      </pc:sldChg>
+      <pc:sldChg chg="modSp mod">
+        <pc:chgData name="Paul Merieux" userId="5067b3df0a83f218" providerId="LiveId" clId="{68BDDC16-0242-43AD-A5CF-C0C7FD622F7F}" dt="2026-07-06T11:00:18.444" v="77" actId="20577"/>
+        <pc:sldMkLst>
+          <pc:docMk/>
+          <pc:sldMk cId="0" sldId="267"/>
+        </pc:sldMkLst>
+        <pc:spChg chg="mod">
+          <ac:chgData name="Paul Merieux" userId="5067b3df0a83f218" providerId="LiveId" clId="{68BDDC16-0242-43AD-A5CF-C0C7FD622F7F}" dt="2026-07-06T11:00:18.444" v="77" actId="20577"/>
+          <ac:spMkLst>
+            <pc:docMk/>
+            <pc:sldMk cId="0" sldId="267"/>
+            <ac:spMk id="304" creationId="{00000000-0000-0000-0000-000000000000}"/>
+          </ac:spMkLst>
+        </pc:spChg>
+        <pc:spChg chg="mod">
+          <ac:chgData name="Paul Merieux" userId="5067b3df0a83f218" providerId="LiveId" clId="{68BDDC16-0242-43AD-A5CF-C0C7FD622F7F}" dt="2026-07-06T11:00:02.695" v="34" actId="20577"/>
+          <ac:spMkLst>
+            <pc:docMk/>
+            <pc:sldMk cId="0" sldId="267"/>
+            <ac:spMk id="305" creationId="{00000000-0000-0000-0000-000000000000}"/>
+          </ac:spMkLst>
+        </pc:spChg>
+      </pc:sldChg>
+      <pc:sldChg chg="modSp mod">
+        <pc:chgData name="Paul Merieux" userId="5067b3df0a83f218" providerId="LiveId" clId="{68BDDC16-0242-43AD-A5CF-C0C7FD622F7F}" dt="2026-07-06T11:00:37.098" v="81" actId="20577"/>
+        <pc:sldMkLst>
+          <pc:docMk/>
+          <pc:sldMk cId="0" sldId="268"/>
+        </pc:sldMkLst>
+        <pc:spChg chg="mod">
+          <ac:chgData name="Paul Merieux" userId="5067b3df0a83f218" providerId="LiveId" clId="{68BDDC16-0242-43AD-A5CF-C0C7FD622F7F}" dt="2026-07-06T11:00:37.098" v="81" actId="20577"/>
+          <ac:spMkLst>
+            <pc:docMk/>
+            <pc:sldMk cId="0" sldId="268"/>
+            <ac:spMk id="325" creationId="{00000000-0000-0000-0000-000000000000}"/>
+          </ac:spMkLst>
+        </pc:spChg>
+      </pc:sldChg>
+      <pc:sldChg chg="modSp mod">
+        <pc:chgData name="Paul Merieux" userId="5067b3df0a83f218" providerId="LiveId" clId="{68BDDC16-0242-43AD-A5CF-C0C7FD622F7F}" dt="2026-07-06T11:02:08.881" v="84" actId="5793"/>
+        <pc:sldMkLst>
+          <pc:docMk/>
+          <pc:sldMk cId="2721376558" sldId="270"/>
+        </pc:sldMkLst>
+        <pc:spChg chg="mod">
+          <ac:chgData name="Paul Merieux" userId="5067b3df0a83f218" providerId="LiveId" clId="{68BDDC16-0242-43AD-A5CF-C0C7FD622F7F}" dt="2026-07-06T11:02:08.881" v="84" actId="5793"/>
+          <ac:spMkLst>
+            <pc:docMk/>
+            <pc:sldMk cId="2721376558" sldId="270"/>
+            <ac:spMk id="6" creationId="{7E025537-3A91-6017-6FB6-BF03A6544262}"/>
+          </ac:spMkLst>
+        </pc:spChg>
+      </pc:sldChg>
+      <pc:sldChg chg="addSp delSp modSp add mod ord modAnim">
+        <pc:chgData name="Paul Merieux" userId="5067b3df0a83f218" providerId="LiveId" clId="{68BDDC16-0242-43AD-A5CF-C0C7FD622F7F}" dt="2026-07-06T10:49:41.480" v="23"/>
+        <pc:sldMkLst>
+          <pc:docMk/>
+          <pc:sldMk cId="4289208017" sldId="273"/>
+        </pc:sldMkLst>
+        <pc:spChg chg="del">
+          <ac:chgData name="Paul Merieux" userId="5067b3df0a83f218" providerId="LiveId" clId="{68BDDC16-0242-43AD-A5CF-C0C7FD622F7F}" dt="2026-07-06T10:44:17.474" v="13" actId="478"/>
+          <ac:spMkLst>
+            <pc:docMk/>
+            <pc:sldMk cId="4289208017" sldId="273"/>
+            <ac:spMk id="138" creationId="{00000000-0000-0000-0000-000000000000}"/>
+          </ac:spMkLst>
+        </pc:spChg>
+        <pc:spChg chg="del mod">
+          <ac:chgData name="Paul Merieux" userId="5067b3df0a83f218" providerId="LiveId" clId="{68BDDC16-0242-43AD-A5CF-C0C7FD622F7F}" dt="2026-07-06T10:44:16.507" v="12" actId="478"/>
+          <ac:spMkLst>
+            <pc:docMk/>
+            <pc:sldMk cId="4289208017" sldId="273"/>
+            <ac:spMk id="139" creationId="{00000000-0000-0000-0000-000000000000}"/>
+          </ac:spMkLst>
+        </pc:spChg>
+        <pc:grpChg chg="del">
+          <ac:chgData name="Paul Merieux" userId="5067b3df0a83f218" providerId="LiveId" clId="{68BDDC16-0242-43AD-A5CF-C0C7FD622F7F}" dt="2026-07-06T10:44:14.638" v="8" actId="478"/>
+          <ac:grpSpMkLst>
+            <pc:docMk/>
+            <pc:sldMk cId="4289208017" sldId="273"/>
+            <ac:grpSpMk id="131" creationId="{00000000-0000-0000-0000-000000000000}"/>
+          </ac:grpSpMkLst>
+        </pc:grpChg>
+        <pc:grpChg chg="del mod">
+          <ac:chgData name="Paul Merieux" userId="5067b3df0a83f218" providerId="LiveId" clId="{68BDDC16-0242-43AD-A5CF-C0C7FD622F7F}" dt="2026-07-06T10:44:15.066" v="10" actId="478"/>
+          <ac:grpSpMkLst>
+            <pc:docMk/>
+            <pc:sldMk cId="4289208017" sldId="273"/>
+            <ac:grpSpMk id="134" creationId="{00000000-0000-0000-0000-000000000000}"/>
+          </ac:grpSpMkLst>
+        </pc:grpChg>
+        <pc:picChg chg="add mod">
+          <ac:chgData name="Paul Merieux" userId="5067b3df0a83f218" providerId="LiveId" clId="{68BDDC16-0242-43AD-A5CF-C0C7FD622F7F}" dt="2026-07-06T10:48:56.587" v="21" actId="14100"/>
+          <ac:picMkLst>
+            <pc:docMk/>
+            <pc:sldMk cId="4289208017" sldId="273"/>
+            <ac:picMk id="2" creationId="{FF1C2DA5-8C3A-E562-9E7C-8234EBC0387A}"/>
+          </ac:picMkLst>
+        </pc:picChg>
+        <pc:picChg chg="del">
+          <ac:chgData name="Paul Merieux" userId="5067b3df0a83f218" providerId="LiveId" clId="{68BDDC16-0242-43AD-A5CF-C0C7FD622F7F}" dt="2026-07-06T10:44:14.233" v="7" actId="478"/>
+          <ac:picMkLst>
+            <pc:docMk/>
+            <pc:sldMk cId="4289208017" sldId="273"/>
+            <ac:picMk id="129" creationId="{00000000-0000-0000-0000-000000000000}"/>
+          </ac:picMkLst>
+        </pc:picChg>
+        <pc:picChg chg="del">
+          <ac:chgData name="Paul Merieux" userId="5067b3df0a83f218" providerId="LiveId" clId="{68BDDC16-0242-43AD-A5CF-C0C7FD622F7F}" dt="2026-07-06T10:44:17.992" v="14" actId="478"/>
+          <ac:picMkLst>
+            <pc:docMk/>
+            <pc:sldMk cId="4289208017" sldId="273"/>
+            <ac:picMk id="142" creationId="{00000000-0000-0000-0000-000000000000}"/>
+          </ac:picMkLst>
+        </pc:picChg>
+      </pc:sldChg>
+    </pc:docChg>
+  </pc:docChgLst>
+</pc:chgInfo>
 </file>
 
 <file path=ppt/notesMasters/notesMaster1.xml><?xml version="1.0" encoding="utf-8"?>
@@ -737,8 +945,8 @@
         </p:nvSpPr>
         <p:spPr>
           <a:xfrm>
-            <a:off x="0" y="0"/>
-            <a:ext cx="3000000" cy="3000000"/>
+            <a:off x="-1166813" y="0"/>
+            <a:ext cx="5334001" cy="3000375"/>
           </a:xfrm>
           <a:custGeom>
             <a:avLst/>
@@ -891,6 +1099,300 @@
 </file>
 
 <file path=ppt/notesSlides/notesSlide10.xml><?xml version="1.0" encoding="utf-8"?>
+<p:notes xmlns:a="http://schemas.openxmlformats.org/drawingml/2006/main" xmlns:r="http://schemas.openxmlformats.org/officeDocument/2006/relationships" xmlns:p="http://schemas.openxmlformats.org/presentationml/2006/main" showMasterSp="0" showMasterPhAnim="0">
+  <p:cSld>
+    <p:spTree>
+      <p:nvGrpSpPr>
+        <p:cNvPr id="1" name="Shape 234"/>
+        <p:cNvGrpSpPr/>
+        <p:nvPr/>
+      </p:nvGrpSpPr>
+      <p:grpSpPr>
+        <a:xfrm>
+          <a:off x="0" y="0"/>
+          <a:ext cx="0" cy="0"/>
+          <a:chOff x="0" y="0"/>
+          <a:chExt cx="0" cy="0"/>
+        </a:xfrm>
+      </p:grpSpPr>
+      <p:sp>
+        <p:nvSpPr>
+          <p:cNvPr id="235" name="Google Shape;235;p9:notes"/>
+          <p:cNvSpPr>
+            <a:spLocks noGrp="1" noRot="1" noChangeAspect="1"/>
+          </p:cNvSpPr>
+          <p:nvPr>
+            <p:ph type="sldImg" idx="2"/>
+          </p:nvPr>
+        </p:nvSpPr>
+        <p:spPr>
+          <a:xfrm>
+            <a:off x="-1166813" y="0"/>
+            <a:ext cx="5334001" cy="3000375"/>
+          </a:xfrm>
+          <a:custGeom>
+            <a:avLst/>
+            <a:gdLst/>
+            <a:ahLst/>
+            <a:cxnLst/>
+            <a:rect l="l" t="t" r="r" b="b"/>
+            <a:pathLst>
+              <a:path w="120000" h="120000" extrusionOk="0">
+                <a:moveTo>
+                  <a:pt x="0" y="0"/>
+                </a:moveTo>
+                <a:lnTo>
+                  <a:pt x="120000" y="0"/>
+                </a:lnTo>
+                <a:lnTo>
+                  <a:pt x="120000" y="120000"/>
+                </a:lnTo>
+                <a:lnTo>
+                  <a:pt x="0" y="120000"/>
+                </a:lnTo>
+                <a:close/>
+              </a:path>
+            </a:pathLst>
+          </a:custGeom>
+          <a:noFill/>
+          <a:ln>
+            <a:noFill/>
+          </a:ln>
+        </p:spPr>
+      </p:sp>
+      <p:sp>
+        <p:nvSpPr>
+          <p:cNvPr id="236" name="Google Shape;236;p9:notes"/>
+          <p:cNvSpPr txBox="1">
+            <a:spLocks noGrp="1"/>
+          </p:cNvSpPr>
+          <p:nvPr>
+            <p:ph type="body" idx="1"/>
+          </p:nvPr>
+        </p:nvSpPr>
+        <p:spPr>
+          <a:xfrm>
+            <a:off x="0" y="0"/>
+            <a:ext cx="3000000" cy="3000000"/>
+          </a:xfrm>
+          <a:prstGeom prst="rect">
+            <a:avLst/>
+          </a:prstGeom>
+          <a:noFill/>
+          <a:ln>
+            <a:noFill/>
+          </a:ln>
+        </p:spPr>
+        <p:txBody>
+          <a:bodyPr spcFirstLastPara="1" wrap="square" lIns="91425" tIns="45700" rIns="91425" bIns="45700" anchor="t" anchorCtr="0">
+            <a:noAutofit/>
+          </a:bodyPr>
+          <a:lstStyle/>
+          <a:p>
+            <a:pPr marL="0" marR="0" lvl="0" indent="0" algn="l" rtl="0">
+              <a:spcBef>
+                <a:spcPts val="0"/>
+              </a:spcBef>
+              <a:spcAft>
+                <a:spcPts val="0"/>
+              </a:spcAft>
+              <a:buNone/>
+            </a:pPr>
+            <a:r>
+              <a:rPr lang="en-US" sz="1100">
+                <a:solidFill>
+                  <a:schemeClr val="dk1"/>
+                </a:solidFill>
+              </a:rPr>
+              <a:t>D’un côté les jeunes de moins de</a:t>
+            </a:r>
+            <a:r>
+              <a:rPr lang="en-US" sz="1100" b="1">
+                <a:solidFill>
+                  <a:schemeClr val="dk1"/>
+                </a:solidFill>
+              </a:rPr>
+              <a:t> 18 ans</a:t>
+            </a:r>
+            <a:r>
+              <a:rPr lang="en-US" sz="1100">
+                <a:solidFill>
+                  <a:schemeClr val="dk1"/>
+                </a:solidFill>
+              </a:rPr>
+              <a:t>, souvent moins expérimentés, et de l’autre les </a:t>
+            </a:r>
+            <a:r>
+              <a:rPr lang="en-US" sz="1100" b="1">
+                <a:solidFill>
+                  <a:schemeClr val="dk1"/>
+                </a:solidFill>
+              </a:rPr>
+              <a:t>seniors de plus de 65 ans</a:t>
+            </a:r>
+            <a:r>
+              <a:rPr lang="en-US" sz="1100">
+                <a:solidFill>
+                  <a:schemeClr val="dk1"/>
+                </a:solidFill>
+              </a:rPr>
+              <a:t> qui certe plus expérimenté, sont eux, beaucoup plus fragiles physiquement. </a:t>
+            </a:r>
+            <a:endParaRPr sz="1100">
+              <a:solidFill>
+                <a:schemeClr val="dk1"/>
+              </a:solidFill>
+            </a:endParaRPr>
+          </a:p>
+          <a:p>
+            <a:pPr marL="0" marR="0" lvl="0" indent="0" algn="l" rtl="0">
+              <a:spcBef>
+                <a:spcPts val="0"/>
+              </a:spcBef>
+              <a:spcAft>
+                <a:spcPts val="0"/>
+              </a:spcAft>
+              <a:buNone/>
+            </a:pPr>
+            <a:endParaRPr sz="1100">
+              <a:solidFill>
+                <a:schemeClr val="dk1"/>
+              </a:solidFill>
+            </a:endParaRPr>
+          </a:p>
+          <a:p>
+            <a:pPr marL="0" marR="0" lvl="0" indent="0" algn="l" rtl="0">
+              <a:spcBef>
+                <a:spcPts val="0"/>
+              </a:spcBef>
+              <a:spcAft>
+                <a:spcPts val="0"/>
+              </a:spcAft>
+              <a:buNone/>
+            </a:pPr>
+            <a:r>
+              <a:rPr lang="en-US" sz="1100">
+                <a:solidFill>
+                  <a:schemeClr val="dk1"/>
+                </a:solidFill>
+              </a:rPr>
+              <a:t>On noteras aussi , qu’en plus de ces caractéristiques, les hommes ont un sur-risque de </a:t>
+            </a:r>
+            <a:r>
+              <a:rPr lang="en-US" sz="1100" b="1">
+                <a:solidFill>
+                  <a:schemeClr val="dk1"/>
+                </a:solidFill>
+              </a:rPr>
+              <a:t>45 %</a:t>
+            </a:r>
+            <a:r>
+              <a:rPr lang="en-US" sz="1100">
+                <a:solidFill>
+                  <a:schemeClr val="dk1"/>
+                </a:solidFill>
+              </a:rPr>
+              <a:t> d’implication dans un accident grave.</a:t>
+            </a:r>
+            <a:endParaRPr sz="1100">
+              <a:solidFill>
+                <a:schemeClr val="dk1"/>
+              </a:solidFill>
+            </a:endParaRPr>
+          </a:p>
+          <a:p>
+            <a:pPr marL="0" marR="0" lvl="0" indent="0" algn="l" rtl="0">
+              <a:spcBef>
+                <a:spcPts val="0"/>
+              </a:spcBef>
+              <a:spcAft>
+                <a:spcPts val="0"/>
+              </a:spcAft>
+              <a:buNone/>
+            </a:pPr>
+            <a:endParaRPr sz="1200">
+              <a:solidFill>
+                <a:schemeClr val="dk1"/>
+              </a:solidFill>
+              <a:latin typeface="Arial"/>
+              <a:ea typeface="Arial"/>
+              <a:cs typeface="Arial"/>
+              <a:sym typeface="Arial"/>
+            </a:endParaRPr>
+          </a:p>
+        </p:txBody>
+      </p:sp>
+      <p:sp>
+        <p:nvSpPr>
+          <p:cNvPr id="237" name="Google Shape;237;p9:notes"/>
+          <p:cNvSpPr txBox="1">
+            <a:spLocks noGrp="1"/>
+          </p:cNvSpPr>
+          <p:nvPr>
+            <p:ph type="sldNum" idx="12"/>
+          </p:nvPr>
+        </p:nvSpPr>
+        <p:spPr>
+          <a:xfrm>
+            <a:off x="0" y="0"/>
+            <a:ext cx="3000000" cy="3000000"/>
+          </a:xfrm>
+          <a:prstGeom prst="rect">
+            <a:avLst/>
+          </a:prstGeom>
+          <a:noFill/>
+          <a:ln>
+            <a:noFill/>
+          </a:ln>
+        </p:spPr>
+        <p:txBody>
+          <a:bodyPr spcFirstLastPara="1" wrap="square" lIns="91425" tIns="45700" rIns="91425" bIns="45700" anchor="t" anchorCtr="0">
+            <a:noAutofit/>
+          </a:bodyPr>
+          <a:lstStyle/>
+          <a:p>
+            <a:pPr marL="0" marR="0" lvl="0" indent="0" algn="l" rtl="0">
+              <a:spcBef>
+                <a:spcPts val="0"/>
+              </a:spcBef>
+              <a:spcAft>
+                <a:spcPts val="0"/>
+              </a:spcAft>
+              <a:buNone/>
+            </a:pPr>
+            <a:fld id="{00000000-1234-1234-1234-123412341234}" type="slidenum">
+              <a:rPr lang="en-US" sz="1800">
+                <a:solidFill>
+                  <a:schemeClr val="dk1"/>
+                </a:solidFill>
+                <a:latin typeface="Arial"/>
+                <a:ea typeface="Arial"/>
+                <a:cs typeface="Arial"/>
+                <a:sym typeface="Arial"/>
+              </a:rPr>
+              <a:t>10</a:t>
+            </a:fld>
+            <a:endParaRPr sz="1800">
+              <a:solidFill>
+                <a:schemeClr val="dk1"/>
+              </a:solidFill>
+              <a:latin typeface="Arial"/>
+              <a:ea typeface="Arial"/>
+              <a:cs typeface="Arial"/>
+              <a:sym typeface="Arial"/>
+            </a:endParaRPr>
+          </a:p>
+        </p:txBody>
+      </p:sp>
+    </p:spTree>
+  </p:cSld>
+  <p:clrMapOvr>
+    <a:masterClrMapping/>
+  </p:clrMapOvr>
+</p:notes>
+</file>
+
+<file path=ppt/notesSlides/notesSlide11.xml><?xml version="1.0" encoding="utf-8"?>
 <p:notes xmlns:a="http://schemas.openxmlformats.org/drawingml/2006/main" xmlns:r="http://schemas.openxmlformats.org/officeDocument/2006/relationships" xmlns:p="http://schemas.openxmlformats.org/presentationml/2006/main" showMasterSp="0" showMasterPhAnim="0">
   <p:cSld>
     <p:spTree>
@@ -1226,7 +1728,7 @@
                 <a:cs typeface="Arial"/>
                 <a:sym typeface="Arial"/>
               </a:rPr>
-              <a:t>10</a:t>
+              <a:t>11</a:t>
             </a:fld>
             <a:endParaRPr sz="1800">
               <a:solidFill>
@@ -1248,7 +1750,7 @@
 </p:notes>
 </file>
 
-<file path=ppt/notesSlides/notesSlide11.xml><?xml version="1.0" encoding="utf-8"?>
+<file path=ppt/notesSlides/notesSlide12.xml><?xml version="1.0" encoding="utf-8"?>
 <p:notes xmlns:a="http://schemas.openxmlformats.org/drawingml/2006/main" xmlns:r="http://schemas.openxmlformats.org/officeDocument/2006/relationships" xmlns:p="http://schemas.openxmlformats.org/presentationml/2006/main" showMasterSp="0" showMasterPhAnim="0">
   <p:cSld>
     <p:spTree>
@@ -1661,7 +2163,7 @@
                 <a:cs typeface="Arial"/>
                 <a:sym typeface="Arial"/>
               </a:rPr>
-              <a:t>11</a:t>
+              <a:t>12</a:t>
             </a:fld>
             <a:endParaRPr sz="1800">
               <a:solidFill>
@@ -1683,7 +2185,7 @@
 </p:notes>
 </file>
 
-<file path=ppt/notesSlides/notesSlide12.xml><?xml version="1.0" encoding="utf-8"?>
+<file path=ppt/notesSlides/notesSlide13.xml><?xml version="1.0" encoding="utf-8"?>
 <p:notes xmlns:a="http://schemas.openxmlformats.org/drawingml/2006/main" xmlns:r="http://schemas.openxmlformats.org/officeDocument/2006/relationships" xmlns:p="http://schemas.openxmlformats.org/presentationml/2006/main" showMasterSp="0" showMasterPhAnim="0">
   <p:cSld>
     <p:spTree>
@@ -2059,7 +2561,7 @@
                 <a:cs typeface="Arial"/>
                 <a:sym typeface="Arial"/>
               </a:rPr>
-              <a:t>12</a:t>
+              <a:t>13</a:t>
             </a:fld>
             <a:endParaRPr sz="1800">
               <a:solidFill>
@@ -2081,7 +2583,7 @@
 </p:notes>
 </file>
 
-<file path=ppt/notesSlides/notesSlide13.xml><?xml version="1.0" encoding="utf-8"?>
+<file path=ppt/notesSlides/notesSlide14.xml><?xml version="1.0" encoding="utf-8"?>
 <p:notes xmlns:a="http://schemas.openxmlformats.org/drawingml/2006/main" xmlns:r="http://schemas.openxmlformats.org/officeDocument/2006/relationships" xmlns:p="http://schemas.openxmlformats.org/presentationml/2006/main" showMasterSp="0" showMasterPhAnim="0">
   <p:cSld>
     <p:spTree>
@@ -2231,7 +2733,7 @@
             </a:pPr>
             <a:fld id="{00000000-1234-1234-1234-123412341234}" type="slidenum">
               <a:rPr lang="en-US"/>
-              <a:t>13</a:t>
+              <a:t>14</a:t>
             </a:fld>
             <a:endParaRPr/>
           </a:p>
@@ -3502,6 +4004,11 @@
         </p:txBody>
       </p:sp>
     </p:spTree>
+    <p:extLst>
+      <p:ext uri="{BB962C8B-B14F-4D97-AF65-F5344CB8AC3E}">
+        <p14:creationId xmlns:p14="http://schemas.microsoft.com/office/powerpoint/2010/main" val="124431538"/>
+      </p:ext>
+    </p:extLst>
   </p:cSld>
   <p:clrMapOvr>
     <a:masterClrMapping/>
@@ -3510,6 +4017,298 @@
 </file>
 
 <file path=ppt/notesSlides/notesSlide7.xml><?xml version="1.0" encoding="utf-8"?>
+<p:notes xmlns:a="http://schemas.openxmlformats.org/drawingml/2006/main" xmlns:r="http://schemas.openxmlformats.org/officeDocument/2006/relationships" xmlns:p="http://schemas.openxmlformats.org/presentationml/2006/main" showMasterSp="0" showMasterPhAnim="0">
+  <p:cSld>
+    <p:spTree>
+      <p:nvGrpSpPr>
+        <p:cNvPr id="1" name="Shape 124"/>
+        <p:cNvGrpSpPr/>
+        <p:nvPr/>
+      </p:nvGrpSpPr>
+      <p:grpSpPr>
+        <a:xfrm>
+          <a:off x="0" y="0"/>
+          <a:ext cx="0" cy="0"/>
+          <a:chOff x="0" y="0"/>
+          <a:chExt cx="0" cy="0"/>
+        </a:xfrm>
+      </p:grpSpPr>
+      <p:sp>
+        <p:nvSpPr>
+          <p:cNvPr id="125" name="Google Shape;125;p13:notes"/>
+          <p:cNvSpPr>
+            <a:spLocks noGrp="1" noRot="1" noChangeAspect="1"/>
+          </p:cNvSpPr>
+          <p:nvPr>
+            <p:ph type="sldImg" idx="2"/>
+          </p:nvPr>
+        </p:nvSpPr>
+        <p:spPr>
+          <a:xfrm>
+            <a:off x="685800" y="1143000"/>
+            <a:ext cx="5486400" cy="3086100"/>
+          </a:xfrm>
+          <a:custGeom>
+            <a:avLst/>
+            <a:gdLst/>
+            <a:ahLst/>
+            <a:cxnLst/>
+            <a:rect l="l" t="t" r="r" b="b"/>
+            <a:pathLst>
+              <a:path w="120000" h="120000" extrusionOk="0">
+                <a:moveTo>
+                  <a:pt x="0" y="0"/>
+                </a:moveTo>
+                <a:lnTo>
+                  <a:pt x="120000" y="0"/>
+                </a:lnTo>
+                <a:lnTo>
+                  <a:pt x="120000" y="120000"/>
+                </a:lnTo>
+                <a:lnTo>
+                  <a:pt x="0" y="120000"/>
+                </a:lnTo>
+                <a:close/>
+              </a:path>
+            </a:pathLst>
+          </a:custGeom>
+          <a:noFill/>
+          <a:ln w="12700" cap="flat" cmpd="sng">
+            <a:solidFill>
+              <a:srgbClr val="000000"/>
+            </a:solidFill>
+            <a:prstDash val="solid"/>
+            <a:round/>
+            <a:headEnd type="none" w="sm" len="sm"/>
+            <a:tailEnd type="none" w="sm" len="sm"/>
+          </a:ln>
+        </p:spPr>
+      </p:sp>
+      <p:sp>
+        <p:nvSpPr>
+          <p:cNvPr id="126" name="Google Shape;126;p13:notes"/>
+          <p:cNvSpPr txBox="1">
+            <a:spLocks noGrp="1"/>
+          </p:cNvSpPr>
+          <p:nvPr>
+            <p:ph type="body" idx="1"/>
+          </p:nvPr>
+        </p:nvSpPr>
+        <p:spPr>
+          <a:xfrm>
+            <a:off x="685800" y="4400550"/>
+            <a:ext cx="5486400" cy="3600450"/>
+          </a:xfrm>
+          <a:prstGeom prst="rect">
+            <a:avLst/>
+          </a:prstGeom>
+          <a:noFill/>
+          <a:ln>
+            <a:noFill/>
+          </a:ln>
+        </p:spPr>
+        <p:txBody>
+          <a:bodyPr spcFirstLastPara="1" wrap="square" lIns="91425" tIns="45700" rIns="91425" bIns="45700" anchor="t" anchorCtr="0">
+            <a:noAutofit/>
+          </a:bodyPr>
+          <a:lstStyle/>
+          <a:p>
+            <a:pPr marL="0" lvl="0" indent="0" algn="l" rtl="0">
+              <a:lnSpc>
+                <a:spcPct val="100000"/>
+              </a:lnSpc>
+              <a:spcBef>
+                <a:spcPts val="600"/>
+              </a:spcBef>
+              <a:spcAft>
+                <a:spcPts val="0"/>
+              </a:spcAft>
+              <a:buClr>
+                <a:schemeClr val="dk1"/>
+              </a:buClr>
+              <a:buSzPts val="1100"/>
+              <a:buFont typeface="Arial"/>
+              <a:buNone/>
+            </a:pPr>
+            <a:r>
+              <a:rPr lang="en-US" sz="1100">
+                <a:solidFill>
+                  <a:schemeClr val="dk1"/>
+                </a:solidFill>
+              </a:rPr>
+              <a:t>Nous avons créé un rapport Power BI basé sur une architecture en étoile, avec deux onglets : une vue globale et une vue prévention. Les deux sont interactifs et permettent aux acteurs de la sécurité routière d'accéder rapidement aux informations qui les concernent. Pour notre analyse, nous avons choisi de nous focaliser sur les conducteurs, ce qui nous permet d'avoir une lecture plus ciblée et plus actionnable.</a:t>
+            </a:r>
+            <a:endParaRPr sz="1100">
+              <a:solidFill>
+                <a:schemeClr val="dk1"/>
+              </a:solidFill>
+            </a:endParaRPr>
+          </a:p>
+          <a:p>
+            <a:pPr marL="0" lvl="0" indent="0" algn="l" rtl="0">
+              <a:spcBef>
+                <a:spcPts val="600"/>
+              </a:spcBef>
+              <a:spcAft>
+                <a:spcPts val="0"/>
+              </a:spcAft>
+              <a:buClr>
+                <a:schemeClr val="dk1"/>
+              </a:buClr>
+              <a:buSzPts val="1100"/>
+              <a:buFont typeface="Arial"/>
+              <a:buNone/>
+            </a:pPr>
+            <a:endParaRPr sz="1100">
+              <a:solidFill>
+                <a:schemeClr val="dk1"/>
+              </a:solidFill>
+            </a:endParaRPr>
+          </a:p>
+          <a:p>
+            <a:pPr marL="0" lvl="0" indent="0" algn="l" rtl="0">
+              <a:spcBef>
+                <a:spcPts val="600"/>
+              </a:spcBef>
+              <a:spcAft>
+                <a:spcPts val="0"/>
+              </a:spcAft>
+              <a:buClr>
+                <a:schemeClr val="dk1"/>
+              </a:buClr>
+              <a:buSzPts val="1100"/>
+              <a:buFont typeface="Arial"/>
+              <a:buNone/>
+            </a:pPr>
+            <a:endParaRPr sz="1100">
+              <a:solidFill>
+                <a:schemeClr val="dk1"/>
+              </a:solidFill>
+            </a:endParaRPr>
+          </a:p>
+          <a:p>
+            <a:pPr marL="0" lvl="0" indent="0" algn="l" rtl="0">
+              <a:lnSpc>
+                <a:spcPct val="100000"/>
+              </a:lnSpc>
+              <a:spcBef>
+                <a:spcPts val="600"/>
+              </a:spcBef>
+              <a:spcAft>
+                <a:spcPts val="0"/>
+              </a:spcAft>
+              <a:buClr>
+                <a:schemeClr val="dk1"/>
+              </a:buClr>
+              <a:buSzPts val="1100"/>
+              <a:buFont typeface="Arial"/>
+              <a:buNone/>
+            </a:pPr>
+            <a:endParaRPr sz="1100">
+              <a:solidFill>
+                <a:schemeClr val="dk1"/>
+              </a:solidFill>
+            </a:endParaRPr>
+          </a:p>
+          <a:p>
+            <a:pPr marL="0" marR="0" lvl="0" indent="0" algn="l" rtl="0">
+              <a:spcBef>
+                <a:spcPts val="600"/>
+              </a:spcBef>
+              <a:spcAft>
+                <a:spcPts val="0"/>
+              </a:spcAft>
+              <a:buClr>
+                <a:schemeClr val="dk1"/>
+              </a:buClr>
+              <a:buSzPts val="1200"/>
+              <a:buFont typeface="Arial"/>
+              <a:buNone/>
+            </a:pPr>
+            <a:endParaRPr sz="1200">
+              <a:solidFill>
+                <a:schemeClr val="dk1"/>
+              </a:solidFill>
+            </a:endParaRPr>
+          </a:p>
+        </p:txBody>
+      </p:sp>
+      <p:sp>
+        <p:nvSpPr>
+          <p:cNvPr id="127" name="Google Shape;127;p13:notes"/>
+          <p:cNvSpPr txBox="1">
+            <a:spLocks noGrp="1"/>
+          </p:cNvSpPr>
+          <p:nvPr>
+            <p:ph type="sldNum" idx="12"/>
+          </p:nvPr>
+        </p:nvSpPr>
+        <p:spPr>
+          <a:xfrm>
+            <a:off x="3884613" y="8685213"/>
+            <a:ext cx="2971800" cy="458787"/>
+          </a:xfrm>
+          <a:prstGeom prst="rect">
+            <a:avLst/>
+          </a:prstGeom>
+          <a:noFill/>
+          <a:ln>
+            <a:noFill/>
+          </a:ln>
+        </p:spPr>
+        <p:txBody>
+          <a:bodyPr spcFirstLastPara="1" wrap="square" lIns="91425" tIns="45700" rIns="91425" bIns="45700" anchor="b" anchorCtr="0">
+            <a:noAutofit/>
+          </a:bodyPr>
+          <a:lstStyle/>
+          <a:p>
+            <a:pPr marL="0" marR="0" lvl="0" indent="0" algn="r" rtl="0">
+              <a:spcBef>
+                <a:spcPts val="0"/>
+              </a:spcBef>
+              <a:spcAft>
+                <a:spcPts val="0"/>
+              </a:spcAft>
+              <a:buClr>
+                <a:schemeClr val="dk1"/>
+              </a:buClr>
+              <a:buSzPts val="1800"/>
+              <a:buFont typeface="Arial"/>
+              <a:buNone/>
+            </a:pPr>
+            <a:fld id="{00000000-1234-1234-1234-123412341234}" type="slidenum">
+              <a:rPr lang="en-US" sz="1800">
+                <a:solidFill>
+                  <a:schemeClr val="dk1"/>
+                </a:solidFill>
+                <a:latin typeface="Arial"/>
+                <a:ea typeface="Arial"/>
+                <a:cs typeface="Arial"/>
+                <a:sym typeface="Arial"/>
+              </a:rPr>
+              <a:t>7</a:t>
+            </a:fld>
+            <a:endParaRPr sz="1800">
+              <a:solidFill>
+                <a:schemeClr val="dk1"/>
+              </a:solidFill>
+              <a:latin typeface="Arial"/>
+              <a:ea typeface="Arial"/>
+              <a:cs typeface="Arial"/>
+              <a:sym typeface="Arial"/>
+            </a:endParaRPr>
+          </a:p>
+        </p:txBody>
+      </p:sp>
+    </p:spTree>
+  </p:cSld>
+  <p:clrMapOvr>
+    <a:masterClrMapping/>
+  </p:clrMapOvr>
+</p:notes>
+</file>
+
+<file path=ppt/notesSlides/notesSlide8.xml><?xml version="1.0" encoding="utf-8"?>
 <p:notes xmlns:a="http://schemas.openxmlformats.org/drawingml/2006/main" xmlns:r="http://schemas.openxmlformats.org/officeDocument/2006/relationships" xmlns:p="http://schemas.openxmlformats.org/presentationml/2006/main" showMasterSp="0" showMasterPhAnim="0">
   <p:cSld>
     <p:spTree>
@@ -3669,7 +4468,7 @@
                 <a:cs typeface="Arial"/>
                 <a:sym typeface="Arial"/>
               </a:rPr>
-              <a:t>7</a:t>
+              <a:t>8</a:t>
             </a:fld>
             <a:endParaRPr sz="1800">
               <a:solidFill>
@@ -3691,7 +4490,7 @@
 </p:notes>
 </file>
 
-<file path=ppt/notesSlides/notesSlide8.xml><?xml version="1.0" encoding="utf-8"?>
+<file path=ppt/notesSlides/notesSlide9.xml><?xml version="1.0" encoding="utf-8"?>
 <p:notes xmlns:a="http://schemas.openxmlformats.org/drawingml/2006/main" xmlns:r="http://schemas.openxmlformats.org/officeDocument/2006/relationships" xmlns:p="http://schemas.openxmlformats.org/presentationml/2006/main" showMasterSp="0" showMasterPhAnim="0">
   <p:cSld>
     <p:spTree>
@@ -3962,300 +4761,6 @@
       <p:sp>
         <p:nvSpPr>
           <p:cNvPr id="194" name="Google Shape;194;g3d96eeb11c7_0_107:notes"/>
-          <p:cNvSpPr txBox="1">
-            <a:spLocks noGrp="1"/>
-          </p:cNvSpPr>
-          <p:nvPr>
-            <p:ph type="sldNum" idx="12"/>
-          </p:nvPr>
-        </p:nvSpPr>
-        <p:spPr>
-          <a:xfrm>
-            <a:off x="0" y="0"/>
-            <a:ext cx="3000000" cy="3000000"/>
-          </a:xfrm>
-          <a:prstGeom prst="rect">
-            <a:avLst/>
-          </a:prstGeom>
-          <a:noFill/>
-          <a:ln>
-            <a:noFill/>
-          </a:ln>
-        </p:spPr>
-        <p:txBody>
-          <a:bodyPr spcFirstLastPara="1" wrap="square" lIns="91425" tIns="45700" rIns="91425" bIns="45700" anchor="t" anchorCtr="0">
-            <a:noAutofit/>
-          </a:bodyPr>
-          <a:lstStyle/>
-          <a:p>
-            <a:pPr marL="0" marR="0" lvl="0" indent="0" algn="l" rtl="0">
-              <a:spcBef>
-                <a:spcPts val="0"/>
-              </a:spcBef>
-              <a:spcAft>
-                <a:spcPts val="0"/>
-              </a:spcAft>
-              <a:buNone/>
-            </a:pPr>
-            <a:fld id="{00000000-1234-1234-1234-123412341234}" type="slidenum">
-              <a:rPr lang="en-US" sz="1800">
-                <a:solidFill>
-                  <a:schemeClr val="dk1"/>
-                </a:solidFill>
-                <a:latin typeface="Arial"/>
-                <a:ea typeface="Arial"/>
-                <a:cs typeface="Arial"/>
-                <a:sym typeface="Arial"/>
-              </a:rPr>
-              <a:t>8</a:t>
-            </a:fld>
-            <a:endParaRPr sz="1800">
-              <a:solidFill>
-                <a:schemeClr val="dk1"/>
-              </a:solidFill>
-              <a:latin typeface="Arial"/>
-              <a:ea typeface="Arial"/>
-              <a:cs typeface="Arial"/>
-              <a:sym typeface="Arial"/>
-            </a:endParaRPr>
-          </a:p>
-        </p:txBody>
-      </p:sp>
-    </p:spTree>
-  </p:cSld>
-  <p:clrMapOvr>
-    <a:masterClrMapping/>
-  </p:clrMapOvr>
-</p:notes>
-</file>
-
-<file path=ppt/notesSlides/notesSlide9.xml><?xml version="1.0" encoding="utf-8"?>
-<p:notes xmlns:a="http://schemas.openxmlformats.org/drawingml/2006/main" xmlns:r="http://schemas.openxmlformats.org/officeDocument/2006/relationships" xmlns:p="http://schemas.openxmlformats.org/presentationml/2006/main" showMasterSp="0" showMasterPhAnim="0">
-  <p:cSld>
-    <p:spTree>
-      <p:nvGrpSpPr>
-        <p:cNvPr id="1" name="Shape 234"/>
-        <p:cNvGrpSpPr/>
-        <p:nvPr/>
-      </p:nvGrpSpPr>
-      <p:grpSpPr>
-        <a:xfrm>
-          <a:off x="0" y="0"/>
-          <a:ext cx="0" cy="0"/>
-          <a:chOff x="0" y="0"/>
-          <a:chExt cx="0" cy="0"/>
-        </a:xfrm>
-      </p:grpSpPr>
-      <p:sp>
-        <p:nvSpPr>
-          <p:cNvPr id="235" name="Google Shape;235;p9:notes"/>
-          <p:cNvSpPr>
-            <a:spLocks noGrp="1" noRot="1" noChangeAspect="1"/>
-          </p:cNvSpPr>
-          <p:nvPr>
-            <p:ph type="sldImg" idx="2"/>
-          </p:nvPr>
-        </p:nvSpPr>
-        <p:spPr>
-          <a:xfrm>
-            <a:off x="-1166813" y="0"/>
-            <a:ext cx="5334001" cy="3000375"/>
-          </a:xfrm>
-          <a:custGeom>
-            <a:avLst/>
-            <a:gdLst/>
-            <a:ahLst/>
-            <a:cxnLst/>
-            <a:rect l="l" t="t" r="r" b="b"/>
-            <a:pathLst>
-              <a:path w="120000" h="120000" extrusionOk="0">
-                <a:moveTo>
-                  <a:pt x="0" y="0"/>
-                </a:moveTo>
-                <a:lnTo>
-                  <a:pt x="120000" y="0"/>
-                </a:lnTo>
-                <a:lnTo>
-                  <a:pt x="120000" y="120000"/>
-                </a:lnTo>
-                <a:lnTo>
-                  <a:pt x="0" y="120000"/>
-                </a:lnTo>
-                <a:close/>
-              </a:path>
-            </a:pathLst>
-          </a:custGeom>
-          <a:noFill/>
-          <a:ln>
-            <a:noFill/>
-          </a:ln>
-        </p:spPr>
-      </p:sp>
-      <p:sp>
-        <p:nvSpPr>
-          <p:cNvPr id="236" name="Google Shape;236;p9:notes"/>
-          <p:cNvSpPr txBox="1">
-            <a:spLocks noGrp="1"/>
-          </p:cNvSpPr>
-          <p:nvPr>
-            <p:ph type="body" idx="1"/>
-          </p:nvPr>
-        </p:nvSpPr>
-        <p:spPr>
-          <a:xfrm>
-            <a:off x="0" y="0"/>
-            <a:ext cx="3000000" cy="3000000"/>
-          </a:xfrm>
-          <a:prstGeom prst="rect">
-            <a:avLst/>
-          </a:prstGeom>
-          <a:noFill/>
-          <a:ln>
-            <a:noFill/>
-          </a:ln>
-        </p:spPr>
-        <p:txBody>
-          <a:bodyPr spcFirstLastPara="1" wrap="square" lIns="91425" tIns="45700" rIns="91425" bIns="45700" anchor="t" anchorCtr="0">
-            <a:noAutofit/>
-          </a:bodyPr>
-          <a:lstStyle/>
-          <a:p>
-            <a:pPr marL="0" marR="0" lvl="0" indent="0" algn="l" rtl="0">
-              <a:spcBef>
-                <a:spcPts val="0"/>
-              </a:spcBef>
-              <a:spcAft>
-                <a:spcPts val="0"/>
-              </a:spcAft>
-              <a:buNone/>
-            </a:pPr>
-            <a:r>
-              <a:rPr lang="en-US" sz="1100">
-                <a:solidFill>
-                  <a:schemeClr val="dk1"/>
-                </a:solidFill>
-              </a:rPr>
-              <a:t>D’un côté les jeunes de moins de</a:t>
-            </a:r>
-            <a:r>
-              <a:rPr lang="en-US" sz="1100" b="1">
-                <a:solidFill>
-                  <a:schemeClr val="dk1"/>
-                </a:solidFill>
-              </a:rPr>
-              <a:t> 18 ans</a:t>
-            </a:r>
-            <a:r>
-              <a:rPr lang="en-US" sz="1100">
-                <a:solidFill>
-                  <a:schemeClr val="dk1"/>
-                </a:solidFill>
-              </a:rPr>
-              <a:t>, souvent moins expérimentés, et de l’autre les </a:t>
-            </a:r>
-            <a:r>
-              <a:rPr lang="en-US" sz="1100" b="1">
-                <a:solidFill>
-                  <a:schemeClr val="dk1"/>
-                </a:solidFill>
-              </a:rPr>
-              <a:t>seniors de plus de 65 ans</a:t>
-            </a:r>
-            <a:r>
-              <a:rPr lang="en-US" sz="1100">
-                <a:solidFill>
-                  <a:schemeClr val="dk1"/>
-                </a:solidFill>
-              </a:rPr>
-              <a:t> qui certe plus expérimenté, sont eux, beaucoup plus fragiles physiquement. </a:t>
-            </a:r>
-            <a:endParaRPr sz="1100">
-              <a:solidFill>
-                <a:schemeClr val="dk1"/>
-              </a:solidFill>
-            </a:endParaRPr>
-          </a:p>
-          <a:p>
-            <a:pPr marL="0" marR="0" lvl="0" indent="0" algn="l" rtl="0">
-              <a:spcBef>
-                <a:spcPts val="0"/>
-              </a:spcBef>
-              <a:spcAft>
-                <a:spcPts val="0"/>
-              </a:spcAft>
-              <a:buNone/>
-            </a:pPr>
-            <a:endParaRPr sz="1100">
-              <a:solidFill>
-                <a:schemeClr val="dk1"/>
-              </a:solidFill>
-            </a:endParaRPr>
-          </a:p>
-          <a:p>
-            <a:pPr marL="0" marR="0" lvl="0" indent="0" algn="l" rtl="0">
-              <a:spcBef>
-                <a:spcPts val="0"/>
-              </a:spcBef>
-              <a:spcAft>
-                <a:spcPts val="0"/>
-              </a:spcAft>
-              <a:buNone/>
-            </a:pPr>
-            <a:r>
-              <a:rPr lang="en-US" sz="1100">
-                <a:solidFill>
-                  <a:schemeClr val="dk1"/>
-                </a:solidFill>
-              </a:rPr>
-              <a:t>On noteras aussi , qu’en plus de ces caractéristiques, les hommes ont un sur-risque de </a:t>
-            </a:r>
-            <a:r>
-              <a:rPr lang="en-US" sz="1100" b="1">
-                <a:solidFill>
-                  <a:schemeClr val="dk1"/>
-                </a:solidFill>
-              </a:rPr>
-              <a:t>45 %</a:t>
-            </a:r>
-            <a:r>
-              <a:rPr lang="en-US" sz="1100">
-                <a:solidFill>
-                  <a:schemeClr val="dk1"/>
-                </a:solidFill>
-              </a:rPr>
-              <a:t> d’implication dans un accident grave.</a:t>
-            </a:r>
-            <a:endParaRPr sz="1100">
-              <a:solidFill>
-                <a:schemeClr val="dk1"/>
-              </a:solidFill>
-            </a:endParaRPr>
-          </a:p>
-          <a:p>
-            <a:pPr marL="0" marR="0" lvl="0" indent="0" algn="l" rtl="0">
-              <a:spcBef>
-                <a:spcPts val="0"/>
-              </a:spcBef>
-              <a:spcAft>
-                <a:spcPts val="0"/>
-              </a:spcAft>
-              <a:buNone/>
-            </a:pPr>
-            <a:endParaRPr sz="1200">
-              <a:solidFill>
-                <a:schemeClr val="dk1"/>
-              </a:solidFill>
-              <a:latin typeface="Arial"/>
-              <a:ea typeface="Arial"/>
-              <a:cs typeface="Arial"/>
-              <a:sym typeface="Arial"/>
-            </a:endParaRPr>
-          </a:p>
-        </p:txBody>
-      </p:sp>
-      <p:sp>
-        <p:nvSpPr>
-          <p:cNvPr id="237" name="Google Shape;237;p9:notes"/>
           <p:cNvSpPr txBox="1">
             <a:spLocks noGrp="1"/>
           </p:cNvSpPr>
@@ -5480,7 +5985,7 @@
               <a:buNone/>
             </a:pPr>
             <a:r>
-              <a:rPr lang="en-US" sz="1200">
+              <a:rPr lang="en-US" sz="1200" dirty="0" err="1">
                 <a:solidFill>
                   <a:srgbClr val="8899A6"/>
                 </a:solidFill>
@@ -5489,10 +5994,22 @@
                 <a:cs typeface="Calibri"/>
                 <a:sym typeface="Calibri"/>
               </a:rPr>
-              <a:t>Ulrick CUADRA, Baptiste SACUTO, Alexandra VENDEVILLE, Paul MERIEUX </a:t>
+              <a:t>Ulrick</a:t>
+            </a:r>
+            <a:r>
+              <a:rPr lang="en-US" sz="1200" dirty="0">
+                <a:solidFill>
+                  <a:srgbClr val="8899A6"/>
+                </a:solidFill>
+                <a:latin typeface="Calibri"/>
+                <a:ea typeface="Calibri"/>
+                <a:cs typeface="Calibri"/>
+                <a:sym typeface="Calibri"/>
+              </a:rPr>
+              <a:t> CUADRA, Baptiste SACUTO, Alexandra VENDEVILLE, Paul MERIEUX </a:t>
             </a:r>
             <a:br>
-              <a:rPr lang="en-US" sz="1200">
+              <a:rPr lang="en-US" sz="1200" dirty="0">
                 <a:solidFill>
                   <a:srgbClr val="8899A6"/>
                 </a:solidFill>
@@ -5503,7 +6020,7 @@
               </a:rPr>
             </a:br>
             <a:r>
-              <a:rPr lang="en-US" sz="1200" b="0" i="0" u="none" strike="noStrike" cap="none">
+              <a:rPr lang="en-US" sz="1200" b="0" i="0" u="none" strike="noStrike" cap="none" dirty="0">
                 <a:solidFill>
                   <a:srgbClr val="8899A6"/>
                 </a:solidFill>
@@ -5512,10 +6029,10 @@
                 <a:cs typeface="Calibri"/>
                 <a:sym typeface="Calibri"/>
               </a:rPr>
-              <a:t>Avril 2025 </a:t>
-            </a:r>
-            <a:r>
-              <a:rPr lang="en-US" sz="1200">
+              <a:t>Avril 2026 </a:t>
+            </a:r>
+            <a:r>
+              <a:rPr lang="en-US" sz="1200" dirty="0">
                 <a:solidFill>
                   <a:srgbClr val="8899A6"/>
                 </a:solidFill>
@@ -5527,7 +6044,7 @@
               <a:t>/ </a:t>
             </a:r>
             <a:r>
-              <a:rPr lang="en-US" sz="1200" b="0" i="0" u="none" strike="noStrike" cap="none">
+              <a:rPr lang="en-US" sz="1200" b="0" i="0" u="none" strike="noStrike" cap="none" dirty="0">
                 <a:solidFill>
                   <a:srgbClr val="8899A6"/>
                 </a:solidFill>
@@ -5539,7 +6056,7 @@
               <a:t>dafs</a:t>
             </a:r>
             <a:r>
-              <a:rPr lang="en-US" sz="1200">
+              <a:rPr lang="en-US" sz="1200" dirty="0">
                 <a:solidFill>
                   <a:srgbClr val="8899A6"/>
                 </a:solidFill>
@@ -5550,7 +6067,7 @@
               </a:rPr>
               <a:t>-ft-18</a:t>
             </a:r>
-            <a:endParaRPr sz="1200" b="0" i="0" u="none" strike="noStrike" cap="none">
+            <a:endParaRPr sz="1200" b="0" i="0" u="none" strike="noStrike" cap="none" dirty="0">
               <a:solidFill>
                 <a:schemeClr val="dk1"/>
               </a:solidFill>
@@ -5710,6 +6227,983 @@
 </file>
 
 <file path=ppt/slides/slide10.xml><?xml version="1.0" encoding="utf-8"?>
+<p:sld xmlns:a="http://schemas.openxmlformats.org/drawingml/2006/main" xmlns:r="http://schemas.openxmlformats.org/officeDocument/2006/relationships" xmlns:p="http://schemas.openxmlformats.org/presentationml/2006/main">
+  <p:cSld>
+    <p:bg>
+      <p:bgPr>
+        <a:solidFill>
+          <a:srgbClr val="F0F4F8"/>
+        </a:solidFill>
+        <a:effectLst/>
+      </p:bgPr>
+    </p:bg>
+    <p:spTree>
+      <p:nvGrpSpPr>
+        <p:cNvPr id="1" name="Shape 238"/>
+        <p:cNvGrpSpPr/>
+        <p:nvPr/>
+      </p:nvGrpSpPr>
+      <p:grpSpPr>
+        <a:xfrm>
+          <a:off x="0" y="0"/>
+          <a:ext cx="0" cy="0"/>
+          <a:chOff x="0" y="0"/>
+          <a:chExt cx="0" cy="0"/>
+        </a:xfrm>
+      </p:grpSpPr>
+      <p:sp>
+        <p:nvSpPr>
+          <p:cNvPr id="239" name="Google Shape;239;p9"/>
+          <p:cNvSpPr/>
+          <p:nvPr/>
+        </p:nvSpPr>
+        <p:spPr>
+          <a:xfrm>
+            <a:off x="0" y="0"/>
+            <a:ext cx="9144000" cy="640080"/>
+          </a:xfrm>
+          <a:prstGeom prst="rect">
+            <a:avLst/>
+          </a:prstGeom>
+          <a:solidFill>
+            <a:srgbClr val="0D1B2A"/>
+          </a:solidFill>
+          <a:ln w="12700" cap="flat" cmpd="sng">
+            <a:solidFill>
+              <a:srgbClr val="0D1B2A"/>
+            </a:solidFill>
+            <a:prstDash val="solid"/>
+            <a:round/>
+            <a:headEnd type="none" w="sm" len="sm"/>
+            <a:tailEnd type="none" w="sm" len="sm"/>
+          </a:ln>
+        </p:spPr>
+        <p:txBody>
+          <a:bodyPr spcFirstLastPara="1" wrap="square" lIns="91425" tIns="91425" rIns="91425" bIns="91425" anchor="ctr" anchorCtr="0">
+            <a:noAutofit/>
+          </a:bodyPr>
+          <a:lstStyle/>
+          <a:p>
+            <a:pPr marL="0" lvl="0" indent="0" algn="l" rtl="0">
+              <a:spcBef>
+                <a:spcPts val="0"/>
+              </a:spcBef>
+              <a:spcAft>
+                <a:spcPts val="0"/>
+              </a:spcAft>
+              <a:buNone/>
+            </a:pPr>
+            <a:endParaRPr/>
+          </a:p>
+        </p:txBody>
+      </p:sp>
+      <p:sp>
+        <p:nvSpPr>
+          <p:cNvPr id="240" name="Google Shape;240;p9"/>
+          <p:cNvSpPr/>
+          <p:nvPr/>
+        </p:nvSpPr>
+        <p:spPr>
+          <a:xfrm>
+            <a:off x="365760" y="91440"/>
+            <a:ext cx="8412480" cy="457200"/>
+          </a:xfrm>
+          <a:prstGeom prst="rect">
+            <a:avLst/>
+          </a:prstGeom>
+          <a:noFill/>
+          <a:ln>
+            <a:noFill/>
+          </a:ln>
+        </p:spPr>
+        <p:txBody>
+          <a:bodyPr spcFirstLastPara="1" wrap="square" lIns="0" tIns="0" rIns="0" bIns="0" anchor="ctr" anchorCtr="0">
+            <a:noAutofit/>
+          </a:bodyPr>
+          <a:lstStyle/>
+          <a:p>
+            <a:pPr marL="0" marR="0" lvl="0" indent="0" algn="l" rtl="0">
+              <a:spcBef>
+                <a:spcPts val="0"/>
+              </a:spcBef>
+              <a:spcAft>
+                <a:spcPts val="0"/>
+              </a:spcAft>
+              <a:buClr>
+                <a:srgbClr val="FFFFFF"/>
+              </a:buClr>
+              <a:buSzPts val="1600"/>
+              <a:buFont typeface="Calibri"/>
+              <a:buNone/>
+            </a:pPr>
+            <a:r>
+              <a:rPr lang="en-US" sz="1600" b="1">
+                <a:solidFill>
+                  <a:srgbClr val="FFFFFF"/>
+                </a:solidFill>
+                <a:latin typeface="Calibri"/>
+                <a:ea typeface="Calibri"/>
+                <a:cs typeface="Calibri"/>
+                <a:sym typeface="Calibri"/>
+              </a:rPr>
+              <a:t>QUI ?  •  Profil des victimes graves</a:t>
+            </a:r>
+            <a:endParaRPr sz="1600">
+              <a:solidFill>
+                <a:schemeClr val="dk1"/>
+              </a:solidFill>
+              <a:latin typeface="Calibri"/>
+              <a:ea typeface="Calibri"/>
+              <a:cs typeface="Calibri"/>
+              <a:sym typeface="Calibri"/>
+            </a:endParaRPr>
+          </a:p>
+        </p:txBody>
+      </p:sp>
+      <p:sp>
+        <p:nvSpPr>
+          <p:cNvPr id="241" name="Google Shape;241;p9"/>
+          <p:cNvSpPr/>
+          <p:nvPr/>
+        </p:nvSpPr>
+        <p:spPr>
+          <a:xfrm>
+            <a:off x="274320" y="4416046"/>
+            <a:ext cx="8595300" cy="685800"/>
+          </a:xfrm>
+          <a:prstGeom prst="rect">
+            <a:avLst/>
+          </a:prstGeom>
+          <a:solidFill>
+            <a:srgbClr val="0D1B2A"/>
+          </a:solidFill>
+          <a:ln w="12700" cap="flat" cmpd="sng">
+            <a:solidFill>
+              <a:srgbClr val="0D1B2A"/>
+            </a:solidFill>
+            <a:prstDash val="solid"/>
+            <a:round/>
+            <a:headEnd type="none" w="sm" len="sm"/>
+            <a:tailEnd type="none" w="sm" len="sm"/>
+          </a:ln>
+        </p:spPr>
+        <p:txBody>
+          <a:bodyPr spcFirstLastPara="1" wrap="square" lIns="91425" tIns="91425" rIns="91425" bIns="91425" anchor="ctr" anchorCtr="0">
+            <a:noAutofit/>
+          </a:bodyPr>
+          <a:lstStyle/>
+          <a:p>
+            <a:pPr marL="0" lvl="0" indent="0" algn="l" rtl="0">
+              <a:spcBef>
+                <a:spcPts val="0"/>
+              </a:spcBef>
+              <a:spcAft>
+                <a:spcPts val="0"/>
+              </a:spcAft>
+              <a:buNone/>
+            </a:pPr>
+            <a:endParaRPr/>
+          </a:p>
+        </p:txBody>
+      </p:sp>
+      <p:sp>
+        <p:nvSpPr>
+          <p:cNvPr id="242" name="Google Shape;242;p9"/>
+          <p:cNvSpPr/>
+          <p:nvPr/>
+        </p:nvSpPr>
+        <p:spPr>
+          <a:xfrm>
+            <a:off x="457200" y="4489198"/>
+            <a:ext cx="8229600" cy="502800"/>
+          </a:xfrm>
+          <a:prstGeom prst="rect">
+            <a:avLst/>
+          </a:prstGeom>
+          <a:noFill/>
+          <a:ln>
+            <a:noFill/>
+          </a:ln>
+        </p:spPr>
+        <p:txBody>
+          <a:bodyPr spcFirstLastPara="1" wrap="square" lIns="0" tIns="0" rIns="0" bIns="0" anchor="ctr" anchorCtr="0">
+            <a:noAutofit/>
+          </a:bodyPr>
+          <a:lstStyle/>
+          <a:p>
+            <a:pPr marL="0" marR="0" lvl="0" indent="0" algn="l" rtl="0">
+              <a:spcBef>
+                <a:spcPts val="0"/>
+              </a:spcBef>
+              <a:spcAft>
+                <a:spcPts val="0"/>
+              </a:spcAft>
+              <a:buClr>
+                <a:srgbClr val="F1C40F"/>
+              </a:buClr>
+              <a:buSzPts val="1300"/>
+              <a:buFont typeface="Calibri"/>
+              <a:buNone/>
+            </a:pPr>
+            <a:r>
+              <a:rPr lang="en-US" sz="1300" b="1" dirty="0">
+                <a:solidFill>
+                  <a:srgbClr val="F1C40F"/>
+                </a:solidFill>
+                <a:latin typeface="Calibri"/>
+                <a:ea typeface="Calibri"/>
+                <a:cs typeface="Calibri"/>
+                <a:sym typeface="Calibri"/>
+              </a:rPr>
+              <a:t>💡  Deux </a:t>
+            </a:r>
+            <a:r>
+              <a:rPr lang="en-US" sz="1300" b="1" dirty="0" err="1">
+                <a:solidFill>
+                  <a:srgbClr val="F1C40F"/>
+                </a:solidFill>
+                <a:latin typeface="Calibri"/>
+                <a:ea typeface="Calibri"/>
+                <a:cs typeface="Calibri"/>
+                <a:sym typeface="Calibri"/>
+              </a:rPr>
+              <a:t>extrêmes</a:t>
+            </a:r>
+            <a:r>
+              <a:rPr lang="en-US" sz="1300" b="1" dirty="0">
+                <a:solidFill>
+                  <a:srgbClr val="F1C40F"/>
+                </a:solidFill>
+                <a:latin typeface="Calibri"/>
+                <a:ea typeface="Calibri"/>
+                <a:cs typeface="Calibri"/>
+                <a:sym typeface="Calibri"/>
+              </a:rPr>
+              <a:t> </a:t>
+            </a:r>
+            <a:r>
+              <a:rPr lang="en-US" sz="1300" b="1" dirty="0" err="1">
+                <a:solidFill>
+                  <a:srgbClr val="F1C40F"/>
+                </a:solidFill>
+                <a:latin typeface="Calibri"/>
+                <a:ea typeface="Calibri"/>
+                <a:cs typeface="Calibri"/>
+                <a:sym typeface="Calibri"/>
+              </a:rPr>
+              <a:t>vulnérables</a:t>
+            </a:r>
+            <a:r>
+              <a:rPr lang="en-US" sz="1300" b="1" dirty="0">
+                <a:solidFill>
+                  <a:srgbClr val="F1C40F"/>
+                </a:solidFill>
+                <a:latin typeface="Calibri"/>
+                <a:ea typeface="Calibri"/>
+                <a:cs typeface="Calibri"/>
+                <a:sym typeface="Calibri"/>
+              </a:rPr>
+              <a:t> : les </a:t>
+            </a:r>
+            <a:r>
+              <a:rPr lang="en-US" sz="1300" b="1" dirty="0" err="1">
+                <a:solidFill>
+                  <a:srgbClr val="F1C40F"/>
+                </a:solidFill>
+                <a:latin typeface="Calibri"/>
+                <a:ea typeface="Calibri"/>
+                <a:cs typeface="Calibri"/>
+                <a:sym typeface="Calibri"/>
+              </a:rPr>
+              <a:t>moins</a:t>
+            </a:r>
+            <a:r>
+              <a:rPr lang="en-US" sz="1300" b="1" dirty="0">
+                <a:solidFill>
+                  <a:srgbClr val="F1C40F"/>
+                </a:solidFill>
+                <a:latin typeface="Calibri"/>
+                <a:ea typeface="Calibri"/>
+                <a:cs typeface="Calibri"/>
+                <a:sym typeface="Calibri"/>
+              </a:rPr>
+              <a:t> de 18 </a:t>
+            </a:r>
+            <a:r>
+              <a:rPr lang="en-US" sz="1300" b="1" dirty="0" err="1">
+                <a:solidFill>
+                  <a:srgbClr val="F1C40F"/>
+                </a:solidFill>
+                <a:latin typeface="Calibri"/>
+                <a:ea typeface="Calibri"/>
+                <a:cs typeface="Calibri"/>
+                <a:sym typeface="Calibri"/>
+              </a:rPr>
+              <a:t>ans</a:t>
+            </a:r>
+            <a:r>
+              <a:rPr lang="en-US" sz="1300" b="1" dirty="0">
+                <a:solidFill>
+                  <a:srgbClr val="F1C40F"/>
+                </a:solidFill>
+                <a:latin typeface="Calibri"/>
+                <a:ea typeface="Calibri"/>
+                <a:cs typeface="Calibri"/>
+                <a:sym typeface="Calibri"/>
+              </a:rPr>
+              <a:t> (peu </a:t>
+            </a:r>
+            <a:r>
+              <a:rPr lang="en-US" sz="1300" b="1" dirty="0" err="1">
+                <a:solidFill>
+                  <a:srgbClr val="F1C40F"/>
+                </a:solidFill>
+                <a:latin typeface="Calibri"/>
+                <a:ea typeface="Calibri"/>
+                <a:cs typeface="Calibri"/>
+                <a:sym typeface="Calibri"/>
+              </a:rPr>
+              <a:t>expérimenté</a:t>
+            </a:r>
+            <a:r>
+              <a:rPr lang="en-US" sz="1300" b="1" dirty="0">
+                <a:solidFill>
+                  <a:srgbClr val="F1C40F"/>
+                </a:solidFill>
+                <a:latin typeface="Calibri"/>
+                <a:ea typeface="Calibri"/>
+                <a:cs typeface="Calibri"/>
+                <a:sym typeface="Calibri"/>
+              </a:rPr>
+              <a:t>) &amp; les plus de 65 (</a:t>
+            </a:r>
+            <a:r>
+              <a:rPr lang="en-US" sz="1300" b="1" dirty="0" err="1">
+                <a:solidFill>
+                  <a:srgbClr val="F1C40F"/>
+                </a:solidFill>
+                <a:latin typeface="Calibri"/>
+                <a:ea typeface="Calibri"/>
+                <a:cs typeface="Calibri"/>
+                <a:sym typeface="Calibri"/>
+              </a:rPr>
+              <a:t>fragilité</a:t>
+            </a:r>
+            <a:r>
+              <a:rPr lang="en-US" sz="1300" b="1" dirty="0">
+                <a:solidFill>
+                  <a:srgbClr val="F1C40F"/>
+                </a:solidFill>
+                <a:latin typeface="Calibri"/>
+                <a:ea typeface="Calibri"/>
+                <a:cs typeface="Calibri"/>
+                <a:sym typeface="Calibri"/>
+              </a:rPr>
+              <a:t> physique). Les hommes </a:t>
+            </a:r>
+            <a:r>
+              <a:rPr lang="en-US" sz="1300" b="1" dirty="0" err="1">
+                <a:solidFill>
+                  <a:srgbClr val="F1C40F"/>
+                </a:solidFill>
+                <a:latin typeface="Calibri"/>
+                <a:ea typeface="Calibri"/>
+                <a:cs typeface="Calibri"/>
+                <a:sym typeface="Calibri"/>
+              </a:rPr>
+              <a:t>semblent</a:t>
+            </a:r>
+            <a:r>
+              <a:rPr lang="en-US" sz="1300" b="1" dirty="0">
+                <a:solidFill>
+                  <a:srgbClr val="F1C40F"/>
+                </a:solidFill>
+                <a:latin typeface="Calibri"/>
+                <a:ea typeface="Calibri"/>
+                <a:cs typeface="Calibri"/>
+                <a:sym typeface="Calibri"/>
+              </a:rPr>
+              <a:t> plus </a:t>
+            </a:r>
+            <a:r>
+              <a:rPr lang="en-US" sz="1300" b="1" dirty="0" err="1">
+                <a:solidFill>
+                  <a:srgbClr val="F1C40F"/>
+                </a:solidFill>
+                <a:latin typeface="Calibri"/>
+                <a:ea typeface="Calibri"/>
+                <a:cs typeface="Calibri"/>
+                <a:sym typeface="Calibri"/>
+              </a:rPr>
+              <a:t>sujet</a:t>
+            </a:r>
+            <a:r>
+              <a:rPr lang="en-US" sz="1300" b="1" dirty="0">
+                <a:solidFill>
+                  <a:srgbClr val="F1C40F"/>
+                </a:solidFill>
+                <a:latin typeface="Calibri"/>
+                <a:ea typeface="Calibri"/>
+                <a:cs typeface="Calibri"/>
+                <a:sym typeface="Calibri"/>
+              </a:rPr>
+              <a:t> à accident grave que les femmes.</a:t>
+            </a:r>
+            <a:endParaRPr sz="1300" dirty="0">
+              <a:solidFill>
+                <a:schemeClr val="dk1"/>
+              </a:solidFill>
+              <a:latin typeface="Calibri"/>
+              <a:ea typeface="Calibri"/>
+              <a:cs typeface="Calibri"/>
+              <a:sym typeface="Calibri"/>
+            </a:endParaRPr>
+          </a:p>
+        </p:txBody>
+      </p:sp>
+      <p:sp>
+        <p:nvSpPr>
+          <p:cNvPr id="243" name="Google Shape;243;p9"/>
+          <p:cNvSpPr/>
+          <p:nvPr/>
+        </p:nvSpPr>
+        <p:spPr>
+          <a:xfrm>
+            <a:off x="738134" y="836383"/>
+            <a:ext cx="2982900" cy="749700"/>
+          </a:xfrm>
+          <a:prstGeom prst="rect">
+            <a:avLst/>
+          </a:prstGeom>
+          <a:solidFill>
+            <a:srgbClr val="FFFFFF"/>
+          </a:solidFill>
+          <a:ln w="12700" cap="flat" cmpd="sng">
+            <a:solidFill>
+              <a:srgbClr val="FFFFFF"/>
+            </a:solidFill>
+            <a:prstDash val="solid"/>
+            <a:round/>
+            <a:headEnd type="none" w="sm" len="sm"/>
+            <a:tailEnd type="none" w="sm" len="sm"/>
+          </a:ln>
+          <a:effectLst>
+            <a:outerShdw blurRad="101600" dist="38100" dir="8100000" algn="bl" rotWithShape="0">
+              <a:srgbClr val="000000">
+                <a:alpha val="12156"/>
+              </a:srgbClr>
+            </a:outerShdw>
+          </a:effectLst>
+        </p:spPr>
+        <p:txBody>
+          <a:bodyPr spcFirstLastPara="1" wrap="square" lIns="91425" tIns="91425" rIns="91425" bIns="91425" anchor="ctr" anchorCtr="0">
+            <a:noAutofit/>
+          </a:bodyPr>
+          <a:lstStyle/>
+          <a:p>
+            <a:pPr marL="0" lvl="0" indent="0" algn="l" rtl="0">
+              <a:spcBef>
+                <a:spcPts val="0"/>
+              </a:spcBef>
+              <a:spcAft>
+                <a:spcPts val="0"/>
+              </a:spcAft>
+              <a:buNone/>
+            </a:pPr>
+            <a:endParaRPr/>
+          </a:p>
+        </p:txBody>
+      </p:sp>
+      <p:sp>
+        <p:nvSpPr>
+          <p:cNvPr id="244" name="Google Shape;244;p9"/>
+          <p:cNvSpPr/>
+          <p:nvPr/>
+        </p:nvSpPr>
+        <p:spPr>
+          <a:xfrm>
+            <a:off x="738134" y="836383"/>
+            <a:ext cx="63900" cy="749700"/>
+          </a:xfrm>
+          <a:prstGeom prst="rect">
+            <a:avLst/>
+          </a:prstGeom>
+          <a:solidFill>
+            <a:srgbClr val="E67E22"/>
+          </a:solidFill>
+          <a:ln w="12700" cap="flat" cmpd="sng">
+            <a:solidFill>
+              <a:srgbClr val="E67E22"/>
+            </a:solidFill>
+            <a:prstDash val="solid"/>
+            <a:round/>
+            <a:headEnd type="none" w="sm" len="sm"/>
+            <a:tailEnd type="none" w="sm" len="sm"/>
+          </a:ln>
+        </p:spPr>
+        <p:txBody>
+          <a:bodyPr spcFirstLastPara="1" wrap="square" lIns="91425" tIns="91425" rIns="91425" bIns="91425" anchor="ctr" anchorCtr="0">
+            <a:noAutofit/>
+          </a:bodyPr>
+          <a:lstStyle/>
+          <a:p>
+            <a:pPr marL="0" lvl="0" indent="0" algn="l" rtl="0">
+              <a:spcBef>
+                <a:spcPts val="0"/>
+              </a:spcBef>
+              <a:spcAft>
+                <a:spcPts val="0"/>
+              </a:spcAft>
+              <a:buNone/>
+            </a:pPr>
+            <a:endParaRPr/>
+          </a:p>
+        </p:txBody>
+      </p:sp>
+      <p:sp>
+        <p:nvSpPr>
+          <p:cNvPr id="245" name="Google Shape;245;p9"/>
+          <p:cNvSpPr/>
+          <p:nvPr/>
+        </p:nvSpPr>
+        <p:spPr>
+          <a:xfrm>
+            <a:off x="882476" y="944975"/>
+            <a:ext cx="2715000" cy="237600"/>
+          </a:xfrm>
+          <a:prstGeom prst="rect">
+            <a:avLst/>
+          </a:prstGeom>
+          <a:noFill/>
+          <a:ln>
+            <a:noFill/>
+          </a:ln>
+        </p:spPr>
+        <p:txBody>
+          <a:bodyPr spcFirstLastPara="1" wrap="square" lIns="0" tIns="0" rIns="0" bIns="0" anchor="b" anchorCtr="0">
+            <a:noAutofit/>
+          </a:bodyPr>
+          <a:lstStyle/>
+          <a:p>
+            <a:pPr marL="0" marR="0" lvl="0" indent="0" algn="l" rtl="0">
+              <a:spcBef>
+                <a:spcPts val="0"/>
+              </a:spcBef>
+              <a:spcAft>
+                <a:spcPts val="0"/>
+              </a:spcAft>
+              <a:buClr>
+                <a:srgbClr val="C0392B"/>
+              </a:buClr>
+              <a:buSzPts val="1800"/>
+              <a:buFont typeface="Calibri"/>
+              <a:buNone/>
+            </a:pPr>
+            <a:r>
+              <a:rPr lang="en-US" sz="1800" b="1">
+                <a:solidFill>
+                  <a:srgbClr val="E67E22"/>
+                </a:solidFill>
+                <a:latin typeface="Calibri"/>
+                <a:ea typeface="Calibri"/>
+                <a:cs typeface="Calibri"/>
+                <a:sym typeface="Calibri"/>
+              </a:rPr>
+              <a:t>– de 18 ans &amp; 65 ans et +</a:t>
+            </a:r>
+            <a:endParaRPr sz="1800">
+              <a:solidFill>
+                <a:srgbClr val="E67E22"/>
+              </a:solidFill>
+              <a:latin typeface="Calibri"/>
+              <a:ea typeface="Calibri"/>
+              <a:cs typeface="Calibri"/>
+              <a:sym typeface="Calibri"/>
+            </a:endParaRPr>
+          </a:p>
+        </p:txBody>
+      </p:sp>
+      <p:sp>
+        <p:nvSpPr>
+          <p:cNvPr id="246" name="Google Shape;246;p9"/>
+          <p:cNvSpPr/>
+          <p:nvPr/>
+        </p:nvSpPr>
+        <p:spPr>
+          <a:xfrm>
+            <a:off x="934638" y="1259320"/>
+            <a:ext cx="3167100" cy="237600"/>
+          </a:xfrm>
+          <a:prstGeom prst="rect">
+            <a:avLst/>
+          </a:prstGeom>
+          <a:noFill/>
+          <a:ln>
+            <a:noFill/>
+          </a:ln>
+        </p:spPr>
+        <p:txBody>
+          <a:bodyPr spcFirstLastPara="1" wrap="square" lIns="0" tIns="0" rIns="0" bIns="0" anchor="t" anchorCtr="0">
+            <a:noAutofit/>
+          </a:bodyPr>
+          <a:lstStyle/>
+          <a:p>
+            <a:pPr marL="0" marR="0" lvl="0" indent="0" algn="l" rtl="0">
+              <a:spcBef>
+                <a:spcPts val="0"/>
+              </a:spcBef>
+              <a:spcAft>
+                <a:spcPts val="0"/>
+              </a:spcAft>
+              <a:buClr>
+                <a:srgbClr val="0D1B2A"/>
+              </a:buClr>
+              <a:buSzPts val="1100"/>
+              <a:buFont typeface="Calibri"/>
+              <a:buNone/>
+            </a:pPr>
+            <a:r>
+              <a:rPr lang="en-US" sz="1100">
+                <a:solidFill>
+                  <a:srgbClr val="0D1B2A"/>
+                </a:solidFill>
+                <a:latin typeface="Calibri"/>
+                <a:ea typeface="Calibri"/>
+                <a:cs typeface="Calibri"/>
+                <a:sym typeface="Calibri"/>
+              </a:rPr>
+              <a:t>Tranche d’âge la plus à risque d’accident grave</a:t>
+            </a:r>
+            <a:endParaRPr sz="1100">
+              <a:solidFill>
+                <a:schemeClr val="dk1"/>
+              </a:solidFill>
+              <a:latin typeface="Calibri"/>
+              <a:ea typeface="Calibri"/>
+              <a:cs typeface="Calibri"/>
+              <a:sym typeface="Calibri"/>
+            </a:endParaRPr>
+          </a:p>
+        </p:txBody>
+      </p:sp>
+      <p:sp>
+        <p:nvSpPr>
+          <p:cNvPr id="247" name="Google Shape;247;p9"/>
+          <p:cNvSpPr/>
+          <p:nvPr/>
+        </p:nvSpPr>
+        <p:spPr>
+          <a:xfrm>
+            <a:off x="6035475" y="769774"/>
+            <a:ext cx="1780200" cy="1014000"/>
+          </a:xfrm>
+          <a:prstGeom prst="rect">
+            <a:avLst/>
+          </a:prstGeom>
+          <a:solidFill>
+            <a:srgbClr val="FFFFFF"/>
+          </a:solidFill>
+          <a:ln w="12700" cap="flat" cmpd="sng">
+            <a:solidFill>
+              <a:srgbClr val="FFFFFF"/>
+            </a:solidFill>
+            <a:prstDash val="solid"/>
+            <a:round/>
+            <a:headEnd type="none" w="sm" len="sm"/>
+            <a:tailEnd type="none" w="sm" len="sm"/>
+          </a:ln>
+          <a:effectLst>
+            <a:outerShdw blurRad="101600" dist="38100" dir="8100000" algn="bl" rotWithShape="0">
+              <a:srgbClr val="000000">
+                <a:alpha val="12156"/>
+              </a:srgbClr>
+            </a:outerShdw>
+          </a:effectLst>
+        </p:spPr>
+        <p:txBody>
+          <a:bodyPr spcFirstLastPara="1" wrap="square" lIns="91425" tIns="91425" rIns="91425" bIns="91425" anchor="ctr" anchorCtr="0">
+            <a:noAutofit/>
+          </a:bodyPr>
+          <a:lstStyle/>
+          <a:p>
+            <a:pPr marL="0" lvl="0" indent="0" algn="l" rtl="0">
+              <a:spcBef>
+                <a:spcPts val="0"/>
+              </a:spcBef>
+              <a:spcAft>
+                <a:spcPts val="0"/>
+              </a:spcAft>
+              <a:buNone/>
+            </a:pPr>
+            <a:endParaRPr/>
+          </a:p>
+        </p:txBody>
+      </p:sp>
+      <p:sp>
+        <p:nvSpPr>
+          <p:cNvPr id="248" name="Google Shape;248;p9"/>
+          <p:cNvSpPr/>
+          <p:nvPr/>
+        </p:nvSpPr>
+        <p:spPr>
+          <a:xfrm>
+            <a:off x="5976122" y="782975"/>
+            <a:ext cx="63900" cy="1000800"/>
+          </a:xfrm>
+          <a:prstGeom prst="rect">
+            <a:avLst/>
+          </a:prstGeom>
+          <a:solidFill>
+            <a:srgbClr val="C0392B"/>
+          </a:solidFill>
+          <a:ln w="12700" cap="flat" cmpd="sng">
+            <a:solidFill>
+              <a:srgbClr val="C0392B"/>
+            </a:solidFill>
+            <a:prstDash val="solid"/>
+            <a:round/>
+            <a:headEnd type="none" w="sm" len="sm"/>
+            <a:tailEnd type="none" w="sm" len="sm"/>
+          </a:ln>
+        </p:spPr>
+        <p:txBody>
+          <a:bodyPr spcFirstLastPara="1" wrap="square" lIns="91425" tIns="91425" rIns="91425" bIns="91425" anchor="ctr" anchorCtr="0">
+            <a:noAutofit/>
+          </a:bodyPr>
+          <a:lstStyle/>
+          <a:p>
+            <a:pPr marL="0" lvl="0" indent="0" algn="l" rtl="0">
+              <a:spcBef>
+                <a:spcPts val="0"/>
+              </a:spcBef>
+              <a:spcAft>
+                <a:spcPts val="0"/>
+              </a:spcAft>
+              <a:buNone/>
+            </a:pPr>
+            <a:endParaRPr/>
+          </a:p>
+        </p:txBody>
+      </p:sp>
+      <p:sp>
+        <p:nvSpPr>
+          <p:cNvPr id="249" name="Google Shape;249;p9"/>
+          <p:cNvSpPr/>
+          <p:nvPr/>
+        </p:nvSpPr>
+        <p:spPr>
+          <a:xfrm>
+            <a:off x="6172650" y="1257480"/>
+            <a:ext cx="1553100" cy="502800"/>
+          </a:xfrm>
+          <a:prstGeom prst="rect">
+            <a:avLst/>
+          </a:prstGeom>
+          <a:noFill/>
+          <a:ln>
+            <a:noFill/>
+          </a:ln>
+        </p:spPr>
+        <p:txBody>
+          <a:bodyPr spcFirstLastPara="1" wrap="square" lIns="0" tIns="0" rIns="0" bIns="0" anchor="t" anchorCtr="0">
+            <a:noAutofit/>
+          </a:bodyPr>
+          <a:lstStyle/>
+          <a:p>
+            <a:pPr marL="0" marR="0" lvl="0" indent="0" algn="l" rtl="0">
+              <a:spcBef>
+                <a:spcPts val="0"/>
+              </a:spcBef>
+              <a:spcAft>
+                <a:spcPts val="0"/>
+              </a:spcAft>
+              <a:buClr>
+                <a:srgbClr val="0D1B2A"/>
+              </a:buClr>
+              <a:buSzPts val="1100"/>
+              <a:buFont typeface="Calibri"/>
+              <a:buNone/>
+            </a:pPr>
+            <a:r>
+              <a:rPr lang="en-US" sz="1100">
+                <a:solidFill>
+                  <a:srgbClr val="0D1B2A"/>
+                </a:solidFill>
+                <a:latin typeface="Calibri"/>
+                <a:ea typeface="Calibri"/>
+                <a:cs typeface="Calibri"/>
+                <a:sym typeface="Calibri"/>
+              </a:rPr>
+              <a:t>de risque pour les hommes d’avoir un accident + grave que les femmes</a:t>
+            </a:r>
+            <a:endParaRPr sz="1100">
+              <a:solidFill>
+                <a:schemeClr val="dk1"/>
+              </a:solidFill>
+              <a:latin typeface="Calibri"/>
+              <a:ea typeface="Calibri"/>
+              <a:cs typeface="Calibri"/>
+              <a:sym typeface="Calibri"/>
+            </a:endParaRPr>
+          </a:p>
+        </p:txBody>
+      </p:sp>
+      <p:sp>
+        <p:nvSpPr>
+          <p:cNvPr id="250" name="Google Shape;250;p9"/>
+          <p:cNvSpPr/>
+          <p:nvPr/>
+        </p:nvSpPr>
+        <p:spPr>
+          <a:xfrm>
+            <a:off x="6225000" y="868320"/>
+            <a:ext cx="938400" cy="350400"/>
+          </a:xfrm>
+          <a:prstGeom prst="rect">
+            <a:avLst/>
+          </a:prstGeom>
+          <a:noFill/>
+          <a:ln>
+            <a:noFill/>
+          </a:ln>
+        </p:spPr>
+        <p:txBody>
+          <a:bodyPr spcFirstLastPara="1" wrap="square" lIns="0" tIns="0" rIns="0" bIns="0" anchor="ctr" anchorCtr="0">
+            <a:noAutofit/>
+          </a:bodyPr>
+          <a:lstStyle/>
+          <a:p>
+            <a:pPr marL="0" marR="0" lvl="0" indent="0" algn="l" rtl="0">
+              <a:spcBef>
+                <a:spcPts val="0"/>
+              </a:spcBef>
+              <a:spcAft>
+                <a:spcPts val="0"/>
+              </a:spcAft>
+              <a:buClr>
+                <a:srgbClr val="C0392B"/>
+              </a:buClr>
+              <a:buSzPts val="2400"/>
+              <a:buFont typeface="Calibri"/>
+              <a:buNone/>
+            </a:pPr>
+            <a:r>
+              <a:rPr lang="en-US" sz="2400" b="1">
+                <a:solidFill>
+                  <a:srgbClr val="C0392B"/>
+                </a:solidFill>
+                <a:latin typeface="Calibri"/>
+                <a:ea typeface="Calibri"/>
+                <a:cs typeface="Calibri"/>
+                <a:sym typeface="Calibri"/>
+              </a:rPr>
+              <a:t>+ 45%</a:t>
+            </a:r>
+            <a:endParaRPr sz="2400">
+              <a:solidFill>
+                <a:schemeClr val="dk1"/>
+              </a:solidFill>
+              <a:latin typeface="Calibri"/>
+              <a:ea typeface="Calibri"/>
+              <a:cs typeface="Calibri"/>
+              <a:sym typeface="Calibri"/>
+            </a:endParaRPr>
+          </a:p>
+        </p:txBody>
+      </p:sp>
+      <p:cxnSp>
+        <p:nvCxnSpPr>
+          <p:cNvPr id="251" name="Google Shape;251;p9"/>
+          <p:cNvCxnSpPr>
+            <a:endCxn id="241" idx="0"/>
+          </p:cNvCxnSpPr>
+          <p:nvPr/>
+        </p:nvCxnSpPr>
+        <p:spPr>
+          <a:xfrm flipH="1">
+            <a:off x="4571970" y="639946"/>
+            <a:ext cx="20700" cy="3776100"/>
+          </a:xfrm>
+          <a:prstGeom prst="straightConnector1">
+            <a:avLst/>
+          </a:prstGeom>
+          <a:noFill/>
+          <a:ln w="19050" cap="flat" cmpd="sng">
+            <a:solidFill>
+              <a:srgbClr val="C0392B"/>
+            </a:solidFill>
+            <a:prstDash val="dot"/>
+            <a:round/>
+            <a:headEnd type="none" w="med" len="med"/>
+            <a:tailEnd type="none" w="med" len="med"/>
+          </a:ln>
+        </p:spPr>
+      </p:cxnSp>
+      <p:pic>
+        <p:nvPicPr>
+          <p:cNvPr id="252" name="Google Shape;252;p9"/>
+          <p:cNvPicPr preferRelativeResize="0"/>
+          <p:nvPr/>
+        </p:nvPicPr>
+        <p:blipFill>
+          <a:blip r:embed="rId3">
+            <a:alphaModFix/>
+          </a:blip>
+          <a:stretch>
+            <a:fillRect/>
+          </a:stretch>
+        </p:blipFill>
+        <p:spPr>
+          <a:xfrm>
+            <a:off x="950875" y="1973037"/>
+            <a:ext cx="2646604" cy="2056050"/>
+          </a:xfrm>
+          <a:prstGeom prst="rect">
+            <a:avLst/>
+          </a:prstGeom>
+          <a:noFill/>
+          <a:ln>
+            <a:noFill/>
+          </a:ln>
+        </p:spPr>
+      </p:pic>
+      <p:pic>
+        <p:nvPicPr>
+          <p:cNvPr id="253" name="Google Shape;253;p9"/>
+          <p:cNvPicPr preferRelativeResize="0"/>
+          <p:nvPr/>
+        </p:nvPicPr>
+        <p:blipFill>
+          <a:blip r:embed="rId4">
+            <a:alphaModFix/>
+          </a:blip>
+          <a:stretch>
+            <a:fillRect/>
+          </a:stretch>
+        </p:blipFill>
+        <p:spPr>
+          <a:xfrm>
+            <a:off x="5859999" y="2061381"/>
+            <a:ext cx="2026025" cy="1923368"/>
+          </a:xfrm>
+          <a:prstGeom prst="rect">
+            <a:avLst/>
+          </a:prstGeom>
+          <a:noFill/>
+          <a:ln>
+            <a:noFill/>
+          </a:ln>
+        </p:spPr>
+      </p:pic>
+    </p:spTree>
+  </p:cSld>
+  <p:clrMapOvr>
+    <a:masterClrMapping/>
+  </p:clrMapOvr>
+</p:sld>
+</file>
+
+<file path=ppt/slides/slide11.xml><?xml version="1.0" encoding="utf-8"?>
 <p:sld xmlns:a="http://schemas.openxmlformats.org/drawingml/2006/main" xmlns:r="http://schemas.openxmlformats.org/officeDocument/2006/relationships" xmlns:p="http://schemas.openxmlformats.org/presentationml/2006/main">
   <p:cSld>
     <p:bg>
@@ -7772,7 +9266,7 @@
 </p:sld>
 </file>
 
-<file path=ppt/slides/slide11.xml><?xml version="1.0" encoding="utf-8"?>
+<file path=ppt/slides/slide12.xml><?xml version="1.0" encoding="utf-8"?>
 <p:sld xmlns:a="http://schemas.openxmlformats.org/drawingml/2006/main" xmlns:r="http://schemas.openxmlformats.org/officeDocument/2006/relationships" xmlns:p="http://schemas.openxmlformats.org/presentationml/2006/main">
   <p:cSld>
     <p:bg>
@@ -8624,7 +10118,7 @@
               <a:buNone/>
             </a:pPr>
             <a:r>
-              <a:rPr lang="en-US" b="1">
+              <a:rPr lang="en-US" b="1" dirty="0">
                 <a:solidFill>
                   <a:schemeClr val="accent4"/>
                 </a:solidFill>
@@ -8633,9 +10127,81 @@
                 <a:cs typeface="Calibri"/>
                 <a:sym typeface="Calibri"/>
               </a:rPr>
-              <a:t> Renforcer les infrastructures et l’éclairage </a:t>
-            </a:r>
-            <a:endParaRPr b="1">
+              <a:t> </a:t>
+            </a:r>
+            <a:r>
+              <a:rPr lang="en-US" b="1" dirty="0" err="1">
+                <a:solidFill>
+                  <a:schemeClr val="accent4"/>
+                </a:solidFill>
+                <a:latin typeface="Calibri"/>
+                <a:ea typeface="Calibri"/>
+                <a:cs typeface="Calibri"/>
+                <a:sym typeface="Calibri"/>
+              </a:rPr>
+              <a:t>Renforcer</a:t>
+            </a:r>
+            <a:r>
+              <a:rPr lang="en-US" b="1" dirty="0">
+                <a:solidFill>
+                  <a:schemeClr val="accent4"/>
+                </a:solidFill>
+                <a:latin typeface="Calibri"/>
+                <a:ea typeface="Calibri"/>
+                <a:cs typeface="Calibri"/>
+                <a:sym typeface="Calibri"/>
+              </a:rPr>
+              <a:t> </a:t>
+            </a:r>
+            <a:r>
+              <a:rPr lang="en-US" b="1" dirty="0" err="1">
+                <a:solidFill>
+                  <a:schemeClr val="accent4"/>
+                </a:solidFill>
+                <a:latin typeface="Calibri"/>
+                <a:ea typeface="Calibri"/>
+                <a:cs typeface="Calibri"/>
+                <a:sym typeface="Calibri"/>
+              </a:rPr>
+              <a:t>l’éclairage</a:t>
+            </a:r>
+            <a:r>
+              <a:rPr lang="en-US" b="1" dirty="0">
+                <a:solidFill>
+                  <a:schemeClr val="accent4"/>
+                </a:solidFill>
+                <a:latin typeface="Calibri"/>
+                <a:ea typeface="Calibri"/>
+                <a:cs typeface="Calibri"/>
+                <a:sym typeface="Calibri"/>
+              </a:rPr>
+              <a:t> dans les zones </a:t>
+            </a:r>
+            <a:r>
+              <a:rPr lang="en-US" b="1" dirty="0" err="1">
+                <a:solidFill>
+                  <a:schemeClr val="accent4"/>
+                </a:solidFill>
+                <a:latin typeface="Calibri"/>
+                <a:ea typeface="Calibri"/>
+                <a:cs typeface="Calibri"/>
+                <a:sym typeface="Calibri"/>
+              </a:rPr>
+              <a:t>accidentogènes</a:t>
+            </a:r>
+            <a:r>
+              <a:rPr lang="en-US" b="1" dirty="0">
+                <a:solidFill>
+                  <a:schemeClr val="accent4"/>
+                </a:solidFill>
+                <a:latin typeface="Calibri"/>
+                <a:ea typeface="Calibri"/>
+                <a:cs typeface="Calibri"/>
+                <a:sym typeface="Calibri"/>
+              </a:rPr>
+              <a:t> </a:t>
+            </a:r>
+            <a:endParaRPr b="1" dirty="0">
               <a:solidFill>
                 <a:schemeClr val="accent4"/>
               </a:solidFill>
@@ -8757,74 +10323,6 @@
               </a:spcAft>
               <a:buNone/>
             </a:pPr>
-            <a:r>
-              <a:rPr lang="en-US" sz="1600" b="1" dirty="0">
-                <a:solidFill>
-                  <a:schemeClr val="dk1"/>
-                </a:solidFill>
-                <a:latin typeface="Calibri"/>
-                <a:ea typeface="Calibri"/>
-                <a:cs typeface="Calibri"/>
-                <a:sym typeface="Calibri"/>
-              </a:rPr>
-              <a:t>• </a:t>
-            </a:r>
-            <a:r>
-              <a:rPr lang="en-US" sz="1100" b="1" dirty="0">
-                <a:solidFill>
-                  <a:schemeClr val="dk1"/>
-                </a:solidFill>
-              </a:rPr>
-              <a:t>Pose de </a:t>
-            </a:r>
-            <a:r>
-              <a:rPr lang="en-US" sz="1100" b="1" dirty="0" err="1">
-                <a:solidFill>
-                  <a:schemeClr val="dk1"/>
-                </a:solidFill>
-              </a:rPr>
-              <a:t>glissières</a:t>
-            </a:r>
-            <a:r>
-              <a:rPr lang="en-US" sz="1100" b="1" dirty="0">
-                <a:solidFill>
-                  <a:schemeClr val="dk1"/>
-                </a:solidFill>
-              </a:rPr>
-              <a:t> </a:t>
-            </a:r>
-            <a:r>
-              <a:rPr lang="en-US" sz="1100" b="1" dirty="0" err="1">
-                <a:solidFill>
-                  <a:schemeClr val="dk1"/>
-                </a:solidFill>
-              </a:rPr>
-              <a:t>préventives</a:t>
-            </a:r>
-            <a:r>
-              <a:rPr lang="en-US" sz="1100" dirty="0">
-                <a:solidFill>
-                  <a:schemeClr val="dk1"/>
-                </a:solidFill>
-              </a:rPr>
-              <a:t> pour </a:t>
-            </a:r>
-            <a:r>
-              <a:rPr lang="en-US" sz="1100" dirty="0" err="1">
-                <a:solidFill>
-                  <a:schemeClr val="dk1"/>
-                </a:solidFill>
-              </a:rPr>
-              <a:t>réduire</a:t>
-            </a:r>
-            <a:r>
-              <a:rPr lang="en-US" sz="1100" dirty="0">
-                <a:solidFill>
-                  <a:schemeClr val="dk1"/>
-                </a:solidFill>
-              </a:rPr>
-              <a:t> les collisions </a:t>
-            </a:r>
             <a:endParaRPr sz="1100" dirty="0">
               <a:solidFill>
                 <a:schemeClr val="dk1"/>
@@ -9483,7 +10981,7 @@
 </p:sld>
 </file>
 
-<file path=ppt/slides/slide12.xml><?xml version="1.0" encoding="utf-8"?>
+<file path=ppt/slides/slide13.xml><?xml version="1.0" encoding="utf-8"?>
 <p:sld xmlns:a="http://schemas.openxmlformats.org/drawingml/2006/main" xmlns:r="http://schemas.openxmlformats.org/officeDocument/2006/relationships" xmlns:p="http://schemas.openxmlformats.org/presentationml/2006/main">
   <p:cSld>
     <p:bg>
@@ -9800,7 +11298,7 @@
                   <a:srgbClr val="444444"/>
                 </a:solidFill>
               </a:rPr>
-              <a:t>Facteur</a:t>
+              <a:t>Facteurs</a:t>
             </a:r>
             <a:r>
               <a:rPr lang="en-US" sz="1100" b="1" dirty="0">
@@ -9868,7 +11366,7 @@
                   <a:srgbClr val="444444"/>
                 </a:solidFill>
               </a:rPr>
-              <a:t>Facteur</a:t>
+              <a:t>Facteurs</a:t>
             </a:r>
             <a:r>
               <a:rPr lang="en-US" sz="1100" b="1" dirty="0">
@@ -9884,7 +11382,7 @@
                   <a:srgbClr val="444444"/>
                 </a:solidFill>
               </a:rPr>
-              <a:t>légal</a:t>
+              <a:t>légaux</a:t>
             </a:r>
             <a:r>
               <a:rPr lang="en-US" sz="1100" dirty="0">
@@ -10948,7 +12446,7 @@
 </p:sld>
 </file>
 
-<file path=ppt/slides/slide13.xml><?xml version="1.0" encoding="utf-8"?>
+<file path=ppt/slides/slide14.xml><?xml version="1.0" encoding="utf-8"?>
 <p:sld xmlns:a="http://schemas.openxmlformats.org/drawingml/2006/main" xmlns:r="http://schemas.openxmlformats.org/officeDocument/2006/relationships" xmlns:p="http://schemas.openxmlformats.org/presentationml/2006/main">
   <p:cSld>
     <p:bg>
@@ -12831,8 +14329,8 @@
         </p:nvSpPr>
         <p:spPr bwMode="auto">
           <a:xfrm>
-            <a:off x="365760" y="1181222"/>
-            <a:ext cx="8412601" cy="3185487"/>
+            <a:off x="365760" y="1258166"/>
+            <a:ext cx="8412601" cy="3031599"/>
           </a:xfrm>
           <a:prstGeom prst="rect">
             <a:avLst/>
@@ -12983,37 +14481,6 @@
                 <a:latin typeface="Google Sans Text"/>
               </a:rPr>
               <a:t>Alignement de l'équipe (rôles, planification, clarification MVP)</a:t>
-            </a:r>
-          </a:p>
-          <a:p>
-            <a:pPr marL="457200" marR="0" lvl="1" indent="0" algn="l" defTabSz="914400" rtl="0" eaLnBrk="0" fontAlgn="base" latinLnBrk="0" hangingPunct="0">
-              <a:lnSpc>
-                <a:spcPct val="100000"/>
-              </a:lnSpc>
-              <a:spcBef>
-                <a:spcPct val="0"/>
-              </a:spcBef>
-              <a:spcAft>
-                <a:spcPct val="0"/>
-              </a:spcAft>
-              <a:buClrTx/>
-              <a:buSzTx/>
-              <a:buFontTx/>
-              <a:buChar char="•"/>
-              <a:tabLst/>
-            </a:pPr>
-            <a:r>
-              <a:rPr kumimoji="0" lang="fr-FR" altLang="fr-FR" sz="1100" b="0" u="none" strike="noStrike" cap="none" normalizeH="0" baseline="0" dirty="0">
-                <a:ln>
-                  <a:noFill/>
-                </a:ln>
-                <a:solidFill>
-                  <a:schemeClr val="tx1"/>
-                </a:solidFill>
-                <a:effectLst/>
-                <a:latin typeface="Google Sans Text"/>
-              </a:rPr>
-              <a:t>Découverte des données</a:t>
             </a:r>
           </a:p>
           <a:p>
@@ -18653,33 +20120,6 @@
           <a:chExt cx="0" cy="0"/>
         </a:xfrm>
       </p:grpSpPr>
-      <p:pic>
-        <p:nvPicPr>
-          <p:cNvPr id="129" name="Google Shape;129;p13"/>
-          <p:cNvPicPr preferRelativeResize="0"/>
-          <p:nvPr/>
-        </p:nvPicPr>
-        <p:blipFill rotWithShape="1">
-          <a:blip r:embed="rId3">
-            <a:alphaModFix/>
-          </a:blip>
-          <a:srcRect/>
-          <a:stretch/>
-        </p:blipFill>
-        <p:spPr>
-          <a:xfrm>
-            <a:off x="264001" y="1281284"/>
-            <a:ext cx="2620849" cy="1476736"/>
-          </a:xfrm>
-          <a:prstGeom prst="rect">
-            <a:avLst/>
-          </a:prstGeom>
-          <a:noFill/>
-          <a:ln>
-            <a:noFill/>
-          </a:ln>
-        </p:spPr>
-      </p:pic>
       <p:sp>
         <p:nvSpPr>
           <p:cNvPr id="130" name="Google Shape;130;p13"/>
@@ -18743,144 +20183,6 @@
           </a:p>
         </p:txBody>
       </p:sp>
-      <p:grpSp>
-        <p:nvGrpSpPr>
-          <p:cNvPr id="131" name="Google Shape;131;p13"/>
-          <p:cNvGrpSpPr/>
-          <p:nvPr/>
-        </p:nvGrpSpPr>
-        <p:grpSpPr>
-          <a:xfrm>
-            <a:off x="3105946" y="1173756"/>
-            <a:ext cx="2844458" cy="3484088"/>
-            <a:chOff x="2478227" y="1469436"/>
-            <a:chExt cx="3039276" cy="3545424"/>
-          </a:xfrm>
-        </p:grpSpPr>
-        <p:pic>
-          <p:nvPicPr>
-            <p:cNvPr id="132" name="Google Shape;132;p13"/>
-            <p:cNvPicPr preferRelativeResize="0"/>
-            <p:nvPr/>
-          </p:nvPicPr>
-          <p:blipFill rotWithShape="1">
-            <a:blip r:embed="rId4">
-              <a:alphaModFix/>
-            </a:blip>
-            <a:srcRect/>
-            <a:stretch/>
-          </p:blipFill>
-          <p:spPr>
-            <a:xfrm>
-              <a:off x="2478227" y="1469436"/>
-              <a:ext cx="3039276" cy="2229531"/>
-            </a:xfrm>
-            <a:prstGeom prst="rect">
-              <a:avLst/>
-            </a:prstGeom>
-            <a:noFill/>
-            <a:ln>
-              <a:noFill/>
-            </a:ln>
-          </p:spPr>
-        </p:pic>
-        <p:pic>
-          <p:nvPicPr>
-            <p:cNvPr id="133" name="Google Shape;133;p13"/>
-            <p:cNvPicPr preferRelativeResize="0"/>
-            <p:nvPr/>
-          </p:nvPicPr>
-          <p:blipFill rotWithShape="1">
-            <a:blip r:embed="rId5">
-              <a:alphaModFix/>
-            </a:blip>
-            <a:srcRect/>
-            <a:stretch/>
-          </p:blipFill>
-          <p:spPr>
-            <a:xfrm>
-              <a:off x="2478227" y="3420128"/>
-              <a:ext cx="3039276" cy="1594732"/>
-            </a:xfrm>
-            <a:prstGeom prst="rect">
-              <a:avLst/>
-            </a:prstGeom>
-            <a:noFill/>
-            <a:ln>
-              <a:noFill/>
-            </a:ln>
-          </p:spPr>
-        </p:pic>
-      </p:grpSp>
-      <p:grpSp>
-        <p:nvGrpSpPr>
-          <p:cNvPr id="134" name="Google Shape;134;p13"/>
-          <p:cNvGrpSpPr/>
-          <p:nvPr/>
-        </p:nvGrpSpPr>
-        <p:grpSpPr>
-          <a:xfrm>
-            <a:off x="6074218" y="1173805"/>
-            <a:ext cx="2910950" cy="3417712"/>
-            <a:chOff x="5628887" y="1427444"/>
-            <a:chExt cx="3299649" cy="3553454"/>
-          </a:xfrm>
-        </p:grpSpPr>
-        <p:pic>
-          <p:nvPicPr>
-            <p:cNvPr id="135" name="Google Shape;135;p13"/>
-            <p:cNvPicPr preferRelativeResize="0"/>
-            <p:nvPr/>
-          </p:nvPicPr>
-          <p:blipFill rotWithShape="1">
-            <a:blip r:embed="rId6">
-              <a:alphaModFix/>
-            </a:blip>
-            <a:srcRect/>
-            <a:stretch/>
-          </p:blipFill>
-          <p:spPr>
-            <a:xfrm>
-              <a:off x="5647386" y="1427444"/>
-              <a:ext cx="3281150" cy="1798011"/>
-            </a:xfrm>
-            <a:prstGeom prst="rect">
-              <a:avLst/>
-            </a:prstGeom>
-            <a:noFill/>
-            <a:ln>
-              <a:noFill/>
-            </a:ln>
-          </p:spPr>
-        </p:pic>
-        <p:pic>
-          <p:nvPicPr>
-            <p:cNvPr id="136" name="Google Shape;136;p13"/>
-            <p:cNvPicPr preferRelativeResize="0"/>
-            <p:nvPr/>
-          </p:nvPicPr>
-          <p:blipFill rotWithShape="1">
-            <a:blip r:embed="rId7">
-              <a:alphaModFix/>
-            </a:blip>
-            <a:srcRect/>
-            <a:stretch/>
-          </p:blipFill>
-          <p:spPr>
-            <a:xfrm>
-              <a:off x="5628887" y="3078051"/>
-              <a:ext cx="3299649" cy="1902847"/>
-            </a:xfrm>
-            <a:prstGeom prst="rect">
-              <a:avLst/>
-            </a:prstGeom>
-            <a:noFill/>
-            <a:ln>
-              <a:noFill/>
-            </a:ln>
-          </p:spPr>
-        </p:pic>
-      </p:grpSp>
       <p:sp>
         <p:nvSpPr>
           <p:cNvPr id="137" name="Google Shape;137;p13"/>
@@ -18929,112 +20231,6 @@
               <a:cs typeface="Calibri"/>
               <a:sym typeface="Calibri"/>
             </a:endParaRPr>
-          </a:p>
-        </p:txBody>
-      </p:sp>
-      <p:sp>
-        <p:nvSpPr>
-          <p:cNvPr id="138" name="Google Shape;138;p13"/>
-          <p:cNvSpPr txBox="1"/>
-          <p:nvPr/>
-        </p:nvSpPr>
-        <p:spPr>
-          <a:xfrm>
-            <a:off x="6670320" y="803505"/>
-            <a:ext cx="1702971" cy="307777"/>
-          </a:xfrm>
-          <a:prstGeom prst="rect">
-            <a:avLst/>
-          </a:prstGeom>
-          <a:noFill/>
-          <a:ln>
-            <a:noFill/>
-          </a:ln>
-        </p:spPr>
-        <p:txBody>
-          <a:bodyPr spcFirstLastPara="1" wrap="square" lIns="91425" tIns="45700" rIns="91425" bIns="45700" anchor="t" anchorCtr="0">
-            <a:spAutoFit/>
-          </a:bodyPr>
-          <a:lstStyle/>
-          <a:p>
-            <a:pPr marL="0" marR="0" lvl="0" indent="0" algn="l" rtl="0">
-              <a:lnSpc>
-                <a:spcPct val="100000"/>
-              </a:lnSpc>
-              <a:spcBef>
-                <a:spcPts val="0"/>
-              </a:spcBef>
-              <a:spcAft>
-                <a:spcPts val="0"/>
-              </a:spcAft>
-              <a:buNone/>
-            </a:pPr>
-            <a:r>
-              <a:rPr lang="en-US" sz="1400" b="1" i="1" u="none" strike="noStrike" cap="none">
-                <a:solidFill>
-                  <a:schemeClr val="dk1"/>
-                </a:solidFill>
-                <a:latin typeface="Arial"/>
-                <a:ea typeface="Arial"/>
-                <a:cs typeface="Arial"/>
-                <a:sym typeface="Arial"/>
-              </a:rPr>
-              <a:t>Focus Prévention</a:t>
-            </a:r>
-            <a:endParaRPr/>
-          </a:p>
-        </p:txBody>
-      </p:sp>
-      <p:sp>
-        <p:nvSpPr>
-          <p:cNvPr id="139" name="Google Shape;139;p13"/>
-          <p:cNvSpPr txBox="1"/>
-          <p:nvPr/>
-        </p:nvSpPr>
-        <p:spPr>
-          <a:xfrm>
-            <a:off x="3764275" y="775984"/>
-            <a:ext cx="1615449" cy="307777"/>
-          </a:xfrm>
-          <a:prstGeom prst="rect">
-            <a:avLst/>
-          </a:prstGeom>
-          <a:noFill/>
-          <a:ln>
-            <a:noFill/>
-          </a:ln>
-        </p:spPr>
-        <p:txBody>
-          <a:bodyPr spcFirstLastPara="1" wrap="square" lIns="91425" tIns="45700" rIns="91425" bIns="45700" anchor="t" anchorCtr="0">
-            <a:spAutoFit/>
-          </a:bodyPr>
-          <a:lstStyle/>
-          <a:p>
-            <a:pPr marL="0" marR="0" lvl="0" indent="0" algn="l" rtl="0">
-              <a:lnSpc>
-                <a:spcPct val="100000"/>
-              </a:lnSpc>
-              <a:spcBef>
-                <a:spcPts val="0"/>
-              </a:spcBef>
-              <a:spcAft>
-                <a:spcPts val="0"/>
-              </a:spcAft>
-              <a:buNone/>
-            </a:pPr>
-            <a:r>
-              <a:rPr lang="en-US" sz="1400" b="1" i="1" u="none" strike="noStrike" cap="none">
-                <a:solidFill>
-                  <a:schemeClr val="dk1"/>
-                </a:solidFill>
-                <a:latin typeface="Arial"/>
-                <a:ea typeface="Arial"/>
-                <a:cs typeface="Arial"/>
-                <a:sym typeface="Arial"/>
-              </a:rPr>
-              <a:t>Analyse globale</a:t>
-            </a:r>
-            <a:endParaRPr/>
           </a:p>
         </p:txBody>
       </p:sp>
@@ -19149,12 +20345,566 @@
       </p:sp>
       <p:pic>
         <p:nvPicPr>
+          <p:cNvPr id="2" name="Média en ligne 1" title="Jedha - Projet final Power BI - dafs-ft-18">
+            <a:hlinkClick r:id="" action="ppaction://media"/>
+            <a:extLst>
+              <a:ext uri="{FF2B5EF4-FFF2-40B4-BE49-F238E27FC236}">
+                <a16:creationId xmlns:a16="http://schemas.microsoft.com/office/drawing/2014/main" id="{FF1C2DA5-8C3A-E562-9E7C-8234EBC0387A}"/>
+              </a:ext>
+            </a:extLst>
+          </p:cNvPr>
+          <p:cNvPicPr>
+            <a:picLocks noRot="1" noChangeAspect="1"/>
+          </p:cNvPicPr>
+          <p:nvPr>
+            <a:videoFile r:link="rId1"/>
+          </p:nvPr>
+        </p:nvPicPr>
+        <p:blipFill>
+          <a:blip r:embed="rId4"/>
+          <a:stretch>
+            <a:fillRect/>
+          </a:stretch>
+        </p:blipFill>
+        <p:spPr>
+          <a:xfrm>
+            <a:off x="558084" y="876568"/>
+            <a:ext cx="7201437" cy="3829050"/>
+          </a:xfrm>
+          <a:prstGeom prst="rect">
+            <a:avLst/>
+          </a:prstGeom>
+        </p:spPr>
+      </p:pic>
+    </p:spTree>
+    <p:extLst>
+      <p:ext uri="{BB962C8B-B14F-4D97-AF65-F5344CB8AC3E}">
+        <p14:creationId xmlns:p14="http://schemas.microsoft.com/office/powerpoint/2010/main" val="4289208017"/>
+      </p:ext>
+    </p:extLst>
+  </p:cSld>
+  <p:clrMapOvr>
+    <a:masterClrMapping/>
+  </p:clrMapOvr>
+  <p:timing>
+    <p:tnLst>
+      <p:par>
+        <p:cTn id="1" dur="indefinite" restart="never" nodeType="tmRoot">
+          <p:childTnLst>
+            <p:seq concurrent="1" nextAc="seek">
+              <p:cTn id="2" dur="indefinite" nodeType="mainSeq">
+                <p:childTnLst>
+                  <p:par>
+                    <p:cTn id="3" fill="hold">
+                      <p:stCondLst>
+                        <p:cond delay="indefinite"/>
+                      </p:stCondLst>
+                      <p:childTnLst>
+                        <p:par>
+                          <p:cTn id="4" fill="hold">
+                            <p:stCondLst>
+                              <p:cond delay="0"/>
+                            </p:stCondLst>
+                            <p:childTnLst>
+                              <p:par>
+                                <p:cTn id="5" presetID="1" presetClass="mediacall" presetSubtype="0" fill="hold" nodeType="clickEffect">
+                                  <p:stCondLst>
+                                    <p:cond delay="0"/>
+                                  </p:stCondLst>
+                                  <p:childTnLst>
+                                    <p:cmd type="call" cmd="playFrom(0.0)">
+                                      <p:cBhvr>
+                                        <p:cTn id="6" dur="1" fill="hold"/>
+                                        <p:tgtEl>
+                                          <p:spTgt spid="2"/>
+                                        </p:tgtEl>
+                                      </p:cBhvr>
+                                    </p:cmd>
+                                  </p:childTnLst>
+                                </p:cTn>
+                              </p:par>
+                            </p:childTnLst>
+                          </p:cTn>
+                        </p:par>
+                      </p:childTnLst>
+                    </p:cTn>
+                  </p:par>
+                </p:childTnLst>
+              </p:cTn>
+              <p:prevCondLst>
+                <p:cond evt="onPrev" delay="0">
+                  <p:tgtEl>
+                    <p:sldTgt/>
+                  </p:tgtEl>
+                </p:cond>
+              </p:prevCondLst>
+              <p:nextCondLst>
+                <p:cond evt="onNext" delay="0">
+                  <p:tgtEl>
+                    <p:sldTgt/>
+                  </p:tgtEl>
+                </p:cond>
+              </p:nextCondLst>
+            </p:seq>
+            <p:video>
+              <p:cMediaNode vol="80000">
+                <p:cTn id="7" fill="hold" display="0">
+                  <p:stCondLst>
+                    <p:cond delay="indefinite"/>
+                  </p:stCondLst>
+                </p:cTn>
+                <p:tgtEl>
+                  <p:spTgt spid="2"/>
+                </p:tgtEl>
+              </p:cMediaNode>
+            </p:video>
+            <p:seq concurrent="1" nextAc="seek">
+              <p:cTn id="8" restart="whenNotActive" fill="hold" evtFilter="cancelBubble" nodeType="interactiveSeq">
+                <p:stCondLst>
+                  <p:cond evt="onClick" delay="0">
+                    <p:tgtEl>
+                      <p:spTgt spid="2"/>
+                    </p:tgtEl>
+                  </p:cond>
+                </p:stCondLst>
+                <p:endSync evt="end" delay="0">
+                  <p:rtn val="all"/>
+                </p:endSync>
+                <p:childTnLst>
+                  <p:par>
+                    <p:cTn id="9" fill="hold">
+                      <p:stCondLst>
+                        <p:cond delay="0"/>
+                      </p:stCondLst>
+                      <p:childTnLst>
+                        <p:par>
+                          <p:cTn id="10" fill="hold">
+                            <p:stCondLst>
+                              <p:cond delay="0"/>
+                            </p:stCondLst>
+                            <p:childTnLst>
+                              <p:par>
+                                <p:cTn id="11" presetID="2" presetClass="mediacall" presetSubtype="0" fill="hold" nodeType="clickEffect">
+                                  <p:stCondLst>
+                                    <p:cond delay="0"/>
+                                  </p:stCondLst>
+                                  <p:childTnLst>
+                                    <p:cmd type="call" cmd="togglePause">
+                                      <p:cBhvr>
+                                        <p:cTn id="12" dur="1" fill="hold"/>
+                                        <p:tgtEl>
+                                          <p:spTgt spid="2"/>
+                                        </p:tgtEl>
+                                      </p:cBhvr>
+                                    </p:cmd>
+                                  </p:childTnLst>
+                                </p:cTn>
+                              </p:par>
+                            </p:childTnLst>
+                          </p:cTn>
+                        </p:par>
+                      </p:childTnLst>
+                    </p:cTn>
+                  </p:par>
+                </p:childTnLst>
+              </p:cTn>
+              <p:nextCondLst>
+                <p:cond evt="onClick" delay="0">
+                  <p:tgtEl>
+                    <p:spTgt spid="2"/>
+                  </p:tgtEl>
+                </p:cond>
+              </p:nextCondLst>
+            </p:seq>
+          </p:childTnLst>
+        </p:cTn>
+      </p:par>
+    </p:tnLst>
+  </p:timing>
+</p:sld>
+</file>
+
+<file path=ppt/slides/slide7.xml><?xml version="1.0" encoding="utf-8"?>
+<p:sld xmlns:a="http://schemas.openxmlformats.org/drawingml/2006/main" xmlns:r="http://schemas.openxmlformats.org/officeDocument/2006/relationships" xmlns:p="http://schemas.openxmlformats.org/presentationml/2006/main">
+  <p:cSld>
+    <p:spTree>
+      <p:nvGrpSpPr>
+        <p:cNvPr id="1" name="Shape 128"/>
+        <p:cNvGrpSpPr/>
+        <p:nvPr/>
+      </p:nvGrpSpPr>
+      <p:grpSpPr>
+        <a:xfrm>
+          <a:off x="0" y="0"/>
+          <a:ext cx="0" cy="0"/>
+          <a:chOff x="0" y="0"/>
+          <a:chExt cx="0" cy="0"/>
+        </a:xfrm>
+      </p:grpSpPr>
+      <p:pic>
+        <p:nvPicPr>
+          <p:cNvPr id="129" name="Google Shape;129;p13"/>
+          <p:cNvPicPr preferRelativeResize="0"/>
+          <p:nvPr/>
+        </p:nvPicPr>
+        <p:blipFill rotWithShape="1">
+          <a:blip r:embed="rId3">
+            <a:alphaModFix/>
+          </a:blip>
+          <a:srcRect/>
+          <a:stretch/>
+        </p:blipFill>
+        <p:spPr>
+          <a:xfrm>
+            <a:off x="264001" y="1281284"/>
+            <a:ext cx="2620849" cy="1476736"/>
+          </a:xfrm>
+          <a:prstGeom prst="rect">
+            <a:avLst/>
+          </a:prstGeom>
+          <a:noFill/>
+          <a:ln>
+            <a:noFill/>
+          </a:ln>
+        </p:spPr>
+      </p:pic>
+      <p:sp>
+        <p:nvSpPr>
+          <p:cNvPr id="130" name="Google Shape;130;p13"/>
+          <p:cNvSpPr/>
+          <p:nvPr/>
+        </p:nvSpPr>
+        <p:spPr>
+          <a:xfrm>
+            <a:off x="457200" y="204742"/>
+            <a:ext cx="8229600" cy="423703"/>
+          </a:xfrm>
+          <a:prstGeom prst="rect">
+            <a:avLst/>
+          </a:prstGeom>
+          <a:noFill/>
+          <a:ln>
+            <a:noFill/>
+          </a:ln>
+        </p:spPr>
+        <p:txBody>
+          <a:bodyPr spcFirstLastPara="1" wrap="square" lIns="91425" tIns="45700" rIns="91425" bIns="45700" anchor="ctr" anchorCtr="0">
+            <a:noAutofit/>
+          </a:bodyPr>
+          <a:lstStyle/>
+          <a:p>
+            <a:pPr marL="0" marR="0" lvl="0" indent="0" algn="l" rtl="0">
+              <a:spcBef>
+                <a:spcPts val="0"/>
+              </a:spcBef>
+              <a:spcAft>
+                <a:spcPts val="0"/>
+              </a:spcAft>
+              <a:buClr>
+                <a:srgbClr val="FFFFFF"/>
+              </a:buClr>
+              <a:buSzPts val="2800"/>
+              <a:buFont typeface="Calibri"/>
+              <a:buNone/>
+            </a:pPr>
+            <a:r>
+              <a:rPr lang="en-US" sz="2800" b="1">
+                <a:solidFill>
+                  <a:srgbClr val="FFFFFF"/>
+                </a:solidFill>
+                <a:latin typeface="Calibri"/>
+                <a:ea typeface="Calibri"/>
+                <a:cs typeface="Calibri"/>
+                <a:sym typeface="Calibri"/>
+              </a:rPr>
+              <a:t>Power BI - Rapport d’analyse </a:t>
+            </a:r>
+            <a:endParaRPr sz="2800">
+              <a:solidFill>
+                <a:schemeClr val="dk1"/>
+              </a:solidFill>
+              <a:latin typeface="Calibri"/>
+              <a:ea typeface="Calibri"/>
+              <a:cs typeface="Calibri"/>
+              <a:sym typeface="Calibri"/>
+            </a:endParaRPr>
+          </a:p>
+        </p:txBody>
+      </p:sp>
+      <p:sp>
+        <p:nvSpPr>
+          <p:cNvPr id="137" name="Google Shape;137;p13"/>
+          <p:cNvSpPr/>
+          <p:nvPr/>
+        </p:nvSpPr>
+        <p:spPr>
+          <a:xfrm>
+            <a:off x="1168032" y="1008978"/>
+            <a:ext cx="1430100" cy="320100"/>
+          </a:xfrm>
+          <a:prstGeom prst="rect">
+            <a:avLst/>
+          </a:prstGeom>
+          <a:noFill/>
+          <a:ln>
+            <a:noFill/>
+          </a:ln>
+        </p:spPr>
+        <p:txBody>
+          <a:bodyPr spcFirstLastPara="1" wrap="square" lIns="0" tIns="0" rIns="0" bIns="0" anchor="ctr" anchorCtr="0">
+            <a:noAutofit/>
+          </a:bodyPr>
+          <a:lstStyle/>
+          <a:p>
+            <a:pPr marL="0" marR="0" lvl="0" indent="0" algn="ctr" rtl="0">
+              <a:spcBef>
+                <a:spcPts val="0"/>
+              </a:spcBef>
+              <a:spcAft>
+                <a:spcPts val="0"/>
+              </a:spcAft>
+              <a:buClr>
+                <a:srgbClr val="E8F0F7"/>
+              </a:buClr>
+              <a:buSzPts val="1300"/>
+              <a:buFont typeface="Calibri"/>
+              <a:buNone/>
+            </a:pPr>
+            <a:endParaRPr sz="1300" b="0" i="0" u="none" strike="noStrike" cap="none">
+              <a:solidFill>
+                <a:schemeClr val="dk1"/>
+              </a:solidFill>
+              <a:latin typeface="Calibri"/>
+              <a:ea typeface="Calibri"/>
+              <a:cs typeface="Calibri"/>
+              <a:sym typeface="Calibri"/>
+            </a:endParaRPr>
+          </a:p>
+        </p:txBody>
+      </p:sp>
+      <p:sp>
+        <p:nvSpPr>
+          <p:cNvPr id="138" name="Google Shape;138;p13"/>
+          <p:cNvSpPr txBox="1"/>
+          <p:nvPr/>
+        </p:nvSpPr>
+        <p:spPr>
+          <a:xfrm>
+            <a:off x="6670320" y="803505"/>
+            <a:ext cx="1702971" cy="307777"/>
+          </a:xfrm>
+          <a:prstGeom prst="rect">
+            <a:avLst/>
+          </a:prstGeom>
+          <a:noFill/>
+          <a:ln>
+            <a:noFill/>
+          </a:ln>
+        </p:spPr>
+        <p:txBody>
+          <a:bodyPr spcFirstLastPara="1" wrap="square" lIns="91425" tIns="45700" rIns="91425" bIns="45700" anchor="t" anchorCtr="0">
+            <a:spAutoFit/>
+          </a:bodyPr>
+          <a:lstStyle/>
+          <a:p>
+            <a:pPr marL="0" marR="0" lvl="0" indent="0" algn="l" rtl="0">
+              <a:lnSpc>
+                <a:spcPct val="100000"/>
+              </a:lnSpc>
+              <a:spcBef>
+                <a:spcPts val="0"/>
+              </a:spcBef>
+              <a:spcAft>
+                <a:spcPts val="0"/>
+              </a:spcAft>
+              <a:buNone/>
+            </a:pPr>
+            <a:r>
+              <a:rPr lang="en-US" sz="1400" b="1" i="1" u="none" strike="noStrike" cap="none">
+                <a:solidFill>
+                  <a:schemeClr val="dk1"/>
+                </a:solidFill>
+                <a:latin typeface="Arial"/>
+                <a:ea typeface="Arial"/>
+                <a:cs typeface="Arial"/>
+                <a:sym typeface="Arial"/>
+              </a:rPr>
+              <a:t>Focus Prévention</a:t>
+            </a:r>
+            <a:endParaRPr/>
+          </a:p>
+        </p:txBody>
+      </p:sp>
+      <p:sp>
+        <p:nvSpPr>
+          <p:cNvPr id="139" name="Google Shape;139;p13"/>
+          <p:cNvSpPr txBox="1"/>
+          <p:nvPr/>
+        </p:nvSpPr>
+        <p:spPr>
+          <a:xfrm>
+            <a:off x="3764275" y="775984"/>
+            <a:ext cx="1615449" cy="307777"/>
+          </a:xfrm>
+          <a:prstGeom prst="rect">
+            <a:avLst/>
+          </a:prstGeom>
+          <a:noFill/>
+          <a:ln>
+            <a:noFill/>
+          </a:ln>
+        </p:spPr>
+        <p:txBody>
+          <a:bodyPr spcFirstLastPara="1" wrap="square" lIns="91425" tIns="45700" rIns="91425" bIns="45700" anchor="t" anchorCtr="0">
+            <a:spAutoFit/>
+          </a:bodyPr>
+          <a:lstStyle/>
+          <a:p>
+            <a:pPr marL="0" marR="0" lvl="0" indent="0" algn="l" rtl="0">
+              <a:lnSpc>
+                <a:spcPct val="100000"/>
+              </a:lnSpc>
+              <a:spcBef>
+                <a:spcPts val="0"/>
+              </a:spcBef>
+              <a:spcAft>
+                <a:spcPts val="0"/>
+              </a:spcAft>
+              <a:buNone/>
+            </a:pPr>
+            <a:r>
+              <a:rPr lang="en-US" sz="1400" b="1" i="1" u="none" strike="noStrike" cap="none">
+                <a:solidFill>
+                  <a:schemeClr val="dk1"/>
+                </a:solidFill>
+                <a:latin typeface="Arial"/>
+                <a:ea typeface="Arial"/>
+                <a:cs typeface="Arial"/>
+                <a:sym typeface="Arial"/>
+              </a:rPr>
+              <a:t>Analyse globale</a:t>
+            </a:r>
+            <a:endParaRPr/>
+          </a:p>
+        </p:txBody>
+      </p:sp>
+      <p:sp>
+        <p:nvSpPr>
+          <p:cNvPr id="140" name="Google Shape;140;p13"/>
+          <p:cNvSpPr/>
+          <p:nvPr/>
+        </p:nvSpPr>
+        <p:spPr>
+          <a:xfrm>
+            <a:off x="0" y="0"/>
+            <a:ext cx="9144000" cy="640080"/>
+          </a:xfrm>
+          <a:prstGeom prst="rect">
+            <a:avLst/>
+          </a:prstGeom>
+          <a:solidFill>
+            <a:srgbClr val="0D1B2A"/>
+          </a:solidFill>
+          <a:ln w="12700" cap="flat" cmpd="sng">
+            <a:solidFill>
+              <a:srgbClr val="0D1B2A"/>
+            </a:solidFill>
+            <a:prstDash val="solid"/>
+            <a:round/>
+            <a:headEnd type="none" w="sm" len="sm"/>
+            <a:tailEnd type="none" w="sm" len="sm"/>
+          </a:ln>
+        </p:spPr>
+        <p:txBody>
+          <a:bodyPr spcFirstLastPara="1" wrap="square" lIns="91425" tIns="91425" rIns="91425" bIns="91425" anchor="ctr" anchorCtr="0">
+            <a:noAutofit/>
+          </a:bodyPr>
+          <a:lstStyle/>
+          <a:p>
+            <a:pPr marL="0" lvl="0" indent="0" algn="l" rtl="0">
+              <a:spcBef>
+                <a:spcPts val="0"/>
+              </a:spcBef>
+              <a:spcAft>
+                <a:spcPts val="0"/>
+              </a:spcAft>
+              <a:buNone/>
+            </a:pPr>
+            <a:endParaRPr/>
+          </a:p>
+        </p:txBody>
+      </p:sp>
+      <p:sp>
+        <p:nvSpPr>
+          <p:cNvPr id="141" name="Google Shape;141;p13"/>
+          <p:cNvSpPr/>
+          <p:nvPr/>
+        </p:nvSpPr>
+        <p:spPr>
+          <a:xfrm>
+            <a:off x="365760" y="91440"/>
+            <a:ext cx="8412480" cy="457200"/>
+          </a:xfrm>
+          <a:prstGeom prst="rect">
+            <a:avLst/>
+          </a:prstGeom>
+          <a:noFill/>
+          <a:ln>
+            <a:noFill/>
+          </a:ln>
+        </p:spPr>
+        <p:txBody>
+          <a:bodyPr spcFirstLastPara="1" wrap="square" lIns="0" tIns="0" rIns="0" bIns="0" anchor="ctr" anchorCtr="0">
+            <a:noAutofit/>
+          </a:bodyPr>
+          <a:lstStyle/>
+          <a:p>
+            <a:pPr marL="0" marR="0" lvl="0" indent="0" algn="l" rtl="0">
+              <a:spcBef>
+                <a:spcPts val="0"/>
+              </a:spcBef>
+              <a:spcAft>
+                <a:spcPts val="0"/>
+              </a:spcAft>
+              <a:buClr>
+                <a:srgbClr val="FFFFFF"/>
+              </a:buClr>
+              <a:buSzPts val="1600"/>
+              <a:buFont typeface="Calibri"/>
+              <a:buNone/>
+            </a:pPr>
+            <a:r>
+              <a:rPr lang="en-US" sz="1600" b="1">
+                <a:solidFill>
+                  <a:srgbClr val="FFFFFF"/>
+                </a:solidFill>
+                <a:latin typeface="Calibri"/>
+                <a:ea typeface="Calibri"/>
+                <a:cs typeface="Calibri"/>
+                <a:sym typeface="Calibri"/>
+              </a:rPr>
+              <a:t>   RAPPORT - Un vision détaillée et interactive avec PowerBI</a:t>
+            </a:r>
+            <a:endParaRPr sz="1600">
+              <a:solidFill>
+                <a:schemeClr val="dk1"/>
+              </a:solidFill>
+              <a:latin typeface="Calibri"/>
+              <a:ea typeface="Calibri"/>
+              <a:cs typeface="Calibri"/>
+              <a:sym typeface="Calibri"/>
+            </a:endParaRPr>
+          </a:p>
+        </p:txBody>
+      </p:sp>
+      <p:pic>
+        <p:nvPicPr>
           <p:cNvPr id="142" name="Google Shape;142;p13"/>
           <p:cNvPicPr preferRelativeResize="0"/>
           <p:nvPr/>
         </p:nvPicPr>
         <p:blipFill>
-          <a:blip r:embed="rId8">
+          <a:blip r:embed="rId4">
             <a:alphaModFix/>
           </a:blip>
           <a:stretch>
@@ -19173,6 +20923,66 @@
           <a:ln>
             <a:noFill/>
           </a:ln>
+        </p:spPr>
+      </p:pic>
+      <p:pic>
+        <p:nvPicPr>
+          <p:cNvPr id="5" name="Image 4">
+            <a:extLst>
+              <a:ext uri="{FF2B5EF4-FFF2-40B4-BE49-F238E27FC236}">
+                <a16:creationId xmlns:a16="http://schemas.microsoft.com/office/drawing/2014/main" id="{ADA05021-F759-0779-E17D-0E7BE5CD1C45}"/>
+              </a:ext>
+            </a:extLst>
+          </p:cNvPr>
+          <p:cNvPicPr>
+            <a:picLocks noChangeAspect="1"/>
+          </p:cNvPicPr>
+          <p:nvPr/>
+        </p:nvPicPr>
+        <p:blipFill>
+          <a:blip r:embed="rId5"/>
+          <a:stretch>
+            <a:fillRect/>
+          </a:stretch>
+        </p:blipFill>
+        <p:spPr>
+          <a:xfrm>
+            <a:off x="6171500" y="1131781"/>
+            <a:ext cx="2823518" cy="3526063"/>
+          </a:xfrm>
+          <a:prstGeom prst="rect">
+            <a:avLst/>
+          </a:prstGeom>
+        </p:spPr>
+      </p:pic>
+      <p:pic>
+        <p:nvPicPr>
+          <p:cNvPr id="7" name="Image 6">
+            <a:extLst>
+              <a:ext uri="{FF2B5EF4-FFF2-40B4-BE49-F238E27FC236}">
+                <a16:creationId xmlns:a16="http://schemas.microsoft.com/office/drawing/2014/main" id="{3B105513-1BBB-6F71-C7EC-46D668FF80D0}"/>
+              </a:ext>
+            </a:extLst>
+          </p:cNvPr>
+          <p:cNvPicPr>
+            <a:picLocks noChangeAspect="1"/>
+          </p:cNvPicPr>
+          <p:nvPr/>
+        </p:nvPicPr>
+        <p:blipFill>
+          <a:blip r:embed="rId6"/>
+          <a:stretch>
+            <a:fillRect/>
+          </a:stretch>
+        </p:blipFill>
+        <p:spPr>
+          <a:xfrm>
+            <a:off x="3252914" y="1111282"/>
+            <a:ext cx="2762623" cy="3634345"/>
+          </a:xfrm>
+          <a:prstGeom prst="rect">
+            <a:avLst/>
+          </a:prstGeom>
         </p:spPr>
       </p:pic>
     </p:spTree>
@@ -19183,7 +20993,7 @@
 </p:sld>
 </file>
 
-<file path=ppt/slides/slide7.xml><?xml version="1.0" encoding="utf-8"?>
+<file path=ppt/slides/slide8.xml><?xml version="1.0" encoding="utf-8"?>
 <p:sld xmlns:a="http://schemas.openxmlformats.org/drawingml/2006/main" xmlns:r="http://schemas.openxmlformats.org/officeDocument/2006/relationships" xmlns:p="http://schemas.openxmlformats.org/presentationml/2006/main">
   <p:cSld>
     <p:bg>
@@ -20677,7 +22487,7 @@
 </p:sld>
 </file>
 
-<file path=ppt/slides/slide8.xml><?xml version="1.0" encoding="utf-8"?>
+<file path=ppt/slides/slide9.xml><?xml version="1.0" encoding="utf-8"?>
 <p:sld xmlns:a="http://schemas.openxmlformats.org/drawingml/2006/main" xmlns:r="http://schemas.openxmlformats.org/officeDocument/2006/relationships" xmlns:p="http://schemas.openxmlformats.org/presentationml/2006/main">
   <p:cSld>
     <p:bg>
@@ -21762,6 +23572,9 @@
                 <a:solidFill>
                   <a:srgbClr val="E67E22"/>
                 </a:solidFill>
+                <a:highlight>
+                  <a:srgbClr val="FFFF00"/>
+                </a:highlight>
                 <a:latin typeface="Calibri"/>
                 <a:ea typeface="Calibri"/>
                 <a:cs typeface="Calibri"/>
@@ -21773,6 +23586,9 @@
               <a:solidFill>
                 <a:srgbClr val="E67E22"/>
               </a:solidFill>
+              <a:highlight>
+                <a:srgbClr val="FFFF00"/>
+              </a:highlight>
               <a:latin typeface="Calibri"/>
               <a:ea typeface="Calibri"/>
               <a:cs typeface="Calibri"/>
@@ -22301,983 +24117,6 @@
           </a:ln>
         </p:spPr>
       </p:cxnSp>
-    </p:spTree>
-  </p:cSld>
-  <p:clrMapOvr>
-    <a:masterClrMapping/>
-  </p:clrMapOvr>
-</p:sld>
-</file>
-
-<file path=ppt/slides/slide9.xml><?xml version="1.0" encoding="utf-8"?>
-<p:sld xmlns:a="http://schemas.openxmlformats.org/drawingml/2006/main" xmlns:r="http://schemas.openxmlformats.org/officeDocument/2006/relationships" xmlns:p="http://schemas.openxmlformats.org/presentationml/2006/main">
-  <p:cSld>
-    <p:bg>
-      <p:bgPr>
-        <a:solidFill>
-          <a:srgbClr val="F0F4F8"/>
-        </a:solidFill>
-        <a:effectLst/>
-      </p:bgPr>
-    </p:bg>
-    <p:spTree>
-      <p:nvGrpSpPr>
-        <p:cNvPr id="1" name="Shape 238"/>
-        <p:cNvGrpSpPr/>
-        <p:nvPr/>
-      </p:nvGrpSpPr>
-      <p:grpSpPr>
-        <a:xfrm>
-          <a:off x="0" y="0"/>
-          <a:ext cx="0" cy="0"/>
-          <a:chOff x="0" y="0"/>
-          <a:chExt cx="0" cy="0"/>
-        </a:xfrm>
-      </p:grpSpPr>
-      <p:sp>
-        <p:nvSpPr>
-          <p:cNvPr id="239" name="Google Shape;239;p9"/>
-          <p:cNvSpPr/>
-          <p:nvPr/>
-        </p:nvSpPr>
-        <p:spPr>
-          <a:xfrm>
-            <a:off x="0" y="0"/>
-            <a:ext cx="9144000" cy="640080"/>
-          </a:xfrm>
-          <a:prstGeom prst="rect">
-            <a:avLst/>
-          </a:prstGeom>
-          <a:solidFill>
-            <a:srgbClr val="0D1B2A"/>
-          </a:solidFill>
-          <a:ln w="12700" cap="flat" cmpd="sng">
-            <a:solidFill>
-              <a:srgbClr val="0D1B2A"/>
-            </a:solidFill>
-            <a:prstDash val="solid"/>
-            <a:round/>
-            <a:headEnd type="none" w="sm" len="sm"/>
-            <a:tailEnd type="none" w="sm" len="sm"/>
-          </a:ln>
-        </p:spPr>
-        <p:txBody>
-          <a:bodyPr spcFirstLastPara="1" wrap="square" lIns="91425" tIns="91425" rIns="91425" bIns="91425" anchor="ctr" anchorCtr="0">
-            <a:noAutofit/>
-          </a:bodyPr>
-          <a:lstStyle/>
-          <a:p>
-            <a:pPr marL="0" lvl="0" indent="0" algn="l" rtl="0">
-              <a:spcBef>
-                <a:spcPts val="0"/>
-              </a:spcBef>
-              <a:spcAft>
-                <a:spcPts val="0"/>
-              </a:spcAft>
-              <a:buNone/>
-            </a:pPr>
-            <a:endParaRPr/>
-          </a:p>
-        </p:txBody>
-      </p:sp>
-      <p:sp>
-        <p:nvSpPr>
-          <p:cNvPr id="240" name="Google Shape;240;p9"/>
-          <p:cNvSpPr/>
-          <p:nvPr/>
-        </p:nvSpPr>
-        <p:spPr>
-          <a:xfrm>
-            <a:off x="365760" y="91440"/>
-            <a:ext cx="8412480" cy="457200"/>
-          </a:xfrm>
-          <a:prstGeom prst="rect">
-            <a:avLst/>
-          </a:prstGeom>
-          <a:noFill/>
-          <a:ln>
-            <a:noFill/>
-          </a:ln>
-        </p:spPr>
-        <p:txBody>
-          <a:bodyPr spcFirstLastPara="1" wrap="square" lIns="0" tIns="0" rIns="0" bIns="0" anchor="ctr" anchorCtr="0">
-            <a:noAutofit/>
-          </a:bodyPr>
-          <a:lstStyle/>
-          <a:p>
-            <a:pPr marL="0" marR="0" lvl="0" indent="0" algn="l" rtl="0">
-              <a:spcBef>
-                <a:spcPts val="0"/>
-              </a:spcBef>
-              <a:spcAft>
-                <a:spcPts val="0"/>
-              </a:spcAft>
-              <a:buClr>
-                <a:srgbClr val="FFFFFF"/>
-              </a:buClr>
-              <a:buSzPts val="1600"/>
-              <a:buFont typeface="Calibri"/>
-              <a:buNone/>
-            </a:pPr>
-            <a:r>
-              <a:rPr lang="en-US" sz="1600" b="1">
-                <a:solidFill>
-                  <a:srgbClr val="FFFFFF"/>
-                </a:solidFill>
-                <a:latin typeface="Calibri"/>
-                <a:ea typeface="Calibri"/>
-                <a:cs typeface="Calibri"/>
-                <a:sym typeface="Calibri"/>
-              </a:rPr>
-              <a:t>QUI ?  •  Profil des victimes graves</a:t>
-            </a:r>
-            <a:endParaRPr sz="1600">
-              <a:solidFill>
-                <a:schemeClr val="dk1"/>
-              </a:solidFill>
-              <a:latin typeface="Calibri"/>
-              <a:ea typeface="Calibri"/>
-              <a:cs typeface="Calibri"/>
-              <a:sym typeface="Calibri"/>
-            </a:endParaRPr>
-          </a:p>
-        </p:txBody>
-      </p:sp>
-      <p:sp>
-        <p:nvSpPr>
-          <p:cNvPr id="241" name="Google Shape;241;p9"/>
-          <p:cNvSpPr/>
-          <p:nvPr/>
-        </p:nvSpPr>
-        <p:spPr>
-          <a:xfrm>
-            <a:off x="274320" y="4416046"/>
-            <a:ext cx="8595300" cy="685800"/>
-          </a:xfrm>
-          <a:prstGeom prst="rect">
-            <a:avLst/>
-          </a:prstGeom>
-          <a:solidFill>
-            <a:srgbClr val="0D1B2A"/>
-          </a:solidFill>
-          <a:ln w="12700" cap="flat" cmpd="sng">
-            <a:solidFill>
-              <a:srgbClr val="0D1B2A"/>
-            </a:solidFill>
-            <a:prstDash val="solid"/>
-            <a:round/>
-            <a:headEnd type="none" w="sm" len="sm"/>
-            <a:tailEnd type="none" w="sm" len="sm"/>
-          </a:ln>
-        </p:spPr>
-        <p:txBody>
-          <a:bodyPr spcFirstLastPara="1" wrap="square" lIns="91425" tIns="91425" rIns="91425" bIns="91425" anchor="ctr" anchorCtr="0">
-            <a:noAutofit/>
-          </a:bodyPr>
-          <a:lstStyle/>
-          <a:p>
-            <a:pPr marL="0" lvl="0" indent="0" algn="l" rtl="0">
-              <a:spcBef>
-                <a:spcPts val="0"/>
-              </a:spcBef>
-              <a:spcAft>
-                <a:spcPts val="0"/>
-              </a:spcAft>
-              <a:buNone/>
-            </a:pPr>
-            <a:endParaRPr/>
-          </a:p>
-        </p:txBody>
-      </p:sp>
-      <p:sp>
-        <p:nvSpPr>
-          <p:cNvPr id="242" name="Google Shape;242;p9"/>
-          <p:cNvSpPr/>
-          <p:nvPr/>
-        </p:nvSpPr>
-        <p:spPr>
-          <a:xfrm>
-            <a:off x="457200" y="4489198"/>
-            <a:ext cx="8229600" cy="502800"/>
-          </a:xfrm>
-          <a:prstGeom prst="rect">
-            <a:avLst/>
-          </a:prstGeom>
-          <a:noFill/>
-          <a:ln>
-            <a:noFill/>
-          </a:ln>
-        </p:spPr>
-        <p:txBody>
-          <a:bodyPr spcFirstLastPara="1" wrap="square" lIns="0" tIns="0" rIns="0" bIns="0" anchor="ctr" anchorCtr="0">
-            <a:noAutofit/>
-          </a:bodyPr>
-          <a:lstStyle/>
-          <a:p>
-            <a:pPr marL="0" marR="0" lvl="0" indent="0" algn="l" rtl="0">
-              <a:spcBef>
-                <a:spcPts val="0"/>
-              </a:spcBef>
-              <a:spcAft>
-                <a:spcPts val="0"/>
-              </a:spcAft>
-              <a:buClr>
-                <a:srgbClr val="F1C40F"/>
-              </a:buClr>
-              <a:buSzPts val="1300"/>
-              <a:buFont typeface="Calibri"/>
-              <a:buNone/>
-            </a:pPr>
-            <a:r>
-              <a:rPr lang="en-US" sz="1300" b="1" dirty="0">
-                <a:solidFill>
-                  <a:srgbClr val="F1C40F"/>
-                </a:solidFill>
-                <a:latin typeface="Calibri"/>
-                <a:ea typeface="Calibri"/>
-                <a:cs typeface="Calibri"/>
-                <a:sym typeface="Calibri"/>
-              </a:rPr>
-              <a:t>💡  Deux </a:t>
-            </a:r>
-            <a:r>
-              <a:rPr lang="en-US" sz="1300" b="1" dirty="0" err="1">
-                <a:solidFill>
-                  <a:srgbClr val="F1C40F"/>
-                </a:solidFill>
-                <a:latin typeface="Calibri"/>
-                <a:ea typeface="Calibri"/>
-                <a:cs typeface="Calibri"/>
-                <a:sym typeface="Calibri"/>
-              </a:rPr>
-              <a:t>extrêmes</a:t>
-            </a:r>
-            <a:r>
-              <a:rPr lang="en-US" sz="1300" b="1" dirty="0">
-                <a:solidFill>
-                  <a:srgbClr val="F1C40F"/>
-                </a:solidFill>
-                <a:latin typeface="Calibri"/>
-                <a:ea typeface="Calibri"/>
-                <a:cs typeface="Calibri"/>
-                <a:sym typeface="Calibri"/>
-              </a:rPr>
-              <a:t> </a:t>
-            </a:r>
-            <a:r>
-              <a:rPr lang="en-US" sz="1300" b="1" dirty="0" err="1">
-                <a:solidFill>
-                  <a:srgbClr val="F1C40F"/>
-                </a:solidFill>
-                <a:latin typeface="Calibri"/>
-                <a:ea typeface="Calibri"/>
-                <a:cs typeface="Calibri"/>
-                <a:sym typeface="Calibri"/>
-              </a:rPr>
-              <a:t>vulnérables</a:t>
-            </a:r>
-            <a:r>
-              <a:rPr lang="en-US" sz="1300" b="1" dirty="0">
-                <a:solidFill>
-                  <a:srgbClr val="F1C40F"/>
-                </a:solidFill>
-                <a:latin typeface="Calibri"/>
-                <a:ea typeface="Calibri"/>
-                <a:cs typeface="Calibri"/>
-                <a:sym typeface="Calibri"/>
-              </a:rPr>
-              <a:t> : les </a:t>
-            </a:r>
-            <a:r>
-              <a:rPr lang="en-US" sz="1300" b="1" dirty="0" err="1">
-                <a:solidFill>
-                  <a:srgbClr val="F1C40F"/>
-                </a:solidFill>
-                <a:latin typeface="Calibri"/>
-                <a:ea typeface="Calibri"/>
-                <a:cs typeface="Calibri"/>
-                <a:sym typeface="Calibri"/>
-              </a:rPr>
-              <a:t>moins</a:t>
-            </a:r>
-            <a:r>
-              <a:rPr lang="en-US" sz="1300" b="1" dirty="0">
-                <a:solidFill>
-                  <a:srgbClr val="F1C40F"/>
-                </a:solidFill>
-                <a:latin typeface="Calibri"/>
-                <a:ea typeface="Calibri"/>
-                <a:cs typeface="Calibri"/>
-                <a:sym typeface="Calibri"/>
-              </a:rPr>
-              <a:t> de 18 </a:t>
-            </a:r>
-            <a:r>
-              <a:rPr lang="en-US" sz="1300" b="1" dirty="0" err="1">
-                <a:solidFill>
-                  <a:srgbClr val="F1C40F"/>
-                </a:solidFill>
-                <a:latin typeface="Calibri"/>
-                <a:ea typeface="Calibri"/>
-                <a:cs typeface="Calibri"/>
-                <a:sym typeface="Calibri"/>
-              </a:rPr>
-              <a:t>ans</a:t>
-            </a:r>
-            <a:r>
-              <a:rPr lang="en-US" sz="1300" b="1" dirty="0">
-                <a:solidFill>
-                  <a:srgbClr val="F1C40F"/>
-                </a:solidFill>
-                <a:latin typeface="Calibri"/>
-                <a:ea typeface="Calibri"/>
-                <a:cs typeface="Calibri"/>
-                <a:sym typeface="Calibri"/>
-              </a:rPr>
-              <a:t> (peu </a:t>
-            </a:r>
-            <a:r>
-              <a:rPr lang="en-US" sz="1300" b="1" dirty="0" err="1">
-                <a:solidFill>
-                  <a:srgbClr val="F1C40F"/>
-                </a:solidFill>
-                <a:latin typeface="Calibri"/>
-                <a:ea typeface="Calibri"/>
-                <a:cs typeface="Calibri"/>
-                <a:sym typeface="Calibri"/>
-              </a:rPr>
-              <a:t>expérimenté</a:t>
-            </a:r>
-            <a:r>
-              <a:rPr lang="en-US" sz="1300" b="1" dirty="0">
-                <a:solidFill>
-                  <a:srgbClr val="F1C40F"/>
-                </a:solidFill>
-                <a:latin typeface="Calibri"/>
-                <a:ea typeface="Calibri"/>
-                <a:cs typeface="Calibri"/>
-                <a:sym typeface="Calibri"/>
-              </a:rPr>
-              <a:t>) &amp; les plus de 65 (</a:t>
-            </a:r>
-            <a:r>
-              <a:rPr lang="en-US" sz="1300" b="1" dirty="0" err="1">
-                <a:solidFill>
-                  <a:srgbClr val="F1C40F"/>
-                </a:solidFill>
-                <a:latin typeface="Calibri"/>
-                <a:ea typeface="Calibri"/>
-                <a:cs typeface="Calibri"/>
-                <a:sym typeface="Calibri"/>
-              </a:rPr>
-              <a:t>fragilité</a:t>
-            </a:r>
-            <a:r>
-              <a:rPr lang="en-US" sz="1300" b="1" dirty="0">
-                <a:solidFill>
-                  <a:srgbClr val="F1C40F"/>
-                </a:solidFill>
-                <a:latin typeface="Calibri"/>
-                <a:ea typeface="Calibri"/>
-                <a:cs typeface="Calibri"/>
-                <a:sym typeface="Calibri"/>
-              </a:rPr>
-              <a:t> physique). Les hommes </a:t>
-            </a:r>
-            <a:r>
-              <a:rPr lang="en-US" sz="1300" b="1" dirty="0" err="1">
-                <a:solidFill>
-                  <a:srgbClr val="F1C40F"/>
-                </a:solidFill>
-                <a:latin typeface="Calibri"/>
-                <a:ea typeface="Calibri"/>
-                <a:cs typeface="Calibri"/>
-                <a:sym typeface="Calibri"/>
-              </a:rPr>
-              <a:t>semblent</a:t>
-            </a:r>
-            <a:r>
-              <a:rPr lang="en-US" sz="1300" b="1" dirty="0">
-                <a:solidFill>
-                  <a:srgbClr val="F1C40F"/>
-                </a:solidFill>
-                <a:latin typeface="Calibri"/>
-                <a:ea typeface="Calibri"/>
-                <a:cs typeface="Calibri"/>
-                <a:sym typeface="Calibri"/>
-              </a:rPr>
-              <a:t> plus </a:t>
-            </a:r>
-            <a:r>
-              <a:rPr lang="en-US" sz="1300" b="1" dirty="0" err="1">
-                <a:solidFill>
-                  <a:srgbClr val="F1C40F"/>
-                </a:solidFill>
-                <a:latin typeface="Calibri"/>
-                <a:ea typeface="Calibri"/>
-                <a:cs typeface="Calibri"/>
-                <a:sym typeface="Calibri"/>
-              </a:rPr>
-              <a:t>sujet</a:t>
-            </a:r>
-            <a:r>
-              <a:rPr lang="en-US" sz="1300" b="1" dirty="0">
-                <a:solidFill>
-                  <a:srgbClr val="F1C40F"/>
-                </a:solidFill>
-                <a:latin typeface="Calibri"/>
-                <a:ea typeface="Calibri"/>
-                <a:cs typeface="Calibri"/>
-                <a:sym typeface="Calibri"/>
-              </a:rPr>
-              <a:t> à accident grave que les femmes.</a:t>
-            </a:r>
-            <a:endParaRPr sz="1300" dirty="0">
-              <a:solidFill>
-                <a:schemeClr val="dk1"/>
-              </a:solidFill>
-              <a:latin typeface="Calibri"/>
-              <a:ea typeface="Calibri"/>
-              <a:cs typeface="Calibri"/>
-              <a:sym typeface="Calibri"/>
-            </a:endParaRPr>
-          </a:p>
-        </p:txBody>
-      </p:sp>
-      <p:sp>
-        <p:nvSpPr>
-          <p:cNvPr id="243" name="Google Shape;243;p9"/>
-          <p:cNvSpPr/>
-          <p:nvPr/>
-        </p:nvSpPr>
-        <p:spPr>
-          <a:xfrm>
-            <a:off x="738134" y="836383"/>
-            <a:ext cx="2982900" cy="749700"/>
-          </a:xfrm>
-          <a:prstGeom prst="rect">
-            <a:avLst/>
-          </a:prstGeom>
-          <a:solidFill>
-            <a:srgbClr val="FFFFFF"/>
-          </a:solidFill>
-          <a:ln w="12700" cap="flat" cmpd="sng">
-            <a:solidFill>
-              <a:srgbClr val="FFFFFF"/>
-            </a:solidFill>
-            <a:prstDash val="solid"/>
-            <a:round/>
-            <a:headEnd type="none" w="sm" len="sm"/>
-            <a:tailEnd type="none" w="sm" len="sm"/>
-          </a:ln>
-          <a:effectLst>
-            <a:outerShdw blurRad="101600" dist="38100" dir="8100000" algn="bl" rotWithShape="0">
-              <a:srgbClr val="000000">
-                <a:alpha val="12156"/>
-              </a:srgbClr>
-            </a:outerShdw>
-          </a:effectLst>
-        </p:spPr>
-        <p:txBody>
-          <a:bodyPr spcFirstLastPara="1" wrap="square" lIns="91425" tIns="91425" rIns="91425" bIns="91425" anchor="ctr" anchorCtr="0">
-            <a:noAutofit/>
-          </a:bodyPr>
-          <a:lstStyle/>
-          <a:p>
-            <a:pPr marL="0" lvl="0" indent="0" algn="l" rtl="0">
-              <a:spcBef>
-                <a:spcPts val="0"/>
-              </a:spcBef>
-              <a:spcAft>
-                <a:spcPts val="0"/>
-              </a:spcAft>
-              <a:buNone/>
-            </a:pPr>
-            <a:endParaRPr/>
-          </a:p>
-        </p:txBody>
-      </p:sp>
-      <p:sp>
-        <p:nvSpPr>
-          <p:cNvPr id="244" name="Google Shape;244;p9"/>
-          <p:cNvSpPr/>
-          <p:nvPr/>
-        </p:nvSpPr>
-        <p:spPr>
-          <a:xfrm>
-            <a:off x="738134" y="836383"/>
-            <a:ext cx="63900" cy="749700"/>
-          </a:xfrm>
-          <a:prstGeom prst="rect">
-            <a:avLst/>
-          </a:prstGeom>
-          <a:solidFill>
-            <a:srgbClr val="E67E22"/>
-          </a:solidFill>
-          <a:ln w="12700" cap="flat" cmpd="sng">
-            <a:solidFill>
-              <a:srgbClr val="E67E22"/>
-            </a:solidFill>
-            <a:prstDash val="solid"/>
-            <a:round/>
-            <a:headEnd type="none" w="sm" len="sm"/>
-            <a:tailEnd type="none" w="sm" len="sm"/>
-          </a:ln>
-        </p:spPr>
-        <p:txBody>
-          <a:bodyPr spcFirstLastPara="1" wrap="square" lIns="91425" tIns="91425" rIns="91425" bIns="91425" anchor="ctr" anchorCtr="0">
-            <a:noAutofit/>
-          </a:bodyPr>
-          <a:lstStyle/>
-          <a:p>
-            <a:pPr marL="0" lvl="0" indent="0" algn="l" rtl="0">
-              <a:spcBef>
-                <a:spcPts val="0"/>
-              </a:spcBef>
-              <a:spcAft>
-                <a:spcPts val="0"/>
-              </a:spcAft>
-              <a:buNone/>
-            </a:pPr>
-            <a:endParaRPr/>
-          </a:p>
-        </p:txBody>
-      </p:sp>
-      <p:sp>
-        <p:nvSpPr>
-          <p:cNvPr id="245" name="Google Shape;245;p9"/>
-          <p:cNvSpPr/>
-          <p:nvPr/>
-        </p:nvSpPr>
-        <p:spPr>
-          <a:xfrm>
-            <a:off x="882476" y="944975"/>
-            <a:ext cx="2715000" cy="237600"/>
-          </a:xfrm>
-          <a:prstGeom prst="rect">
-            <a:avLst/>
-          </a:prstGeom>
-          <a:noFill/>
-          <a:ln>
-            <a:noFill/>
-          </a:ln>
-        </p:spPr>
-        <p:txBody>
-          <a:bodyPr spcFirstLastPara="1" wrap="square" lIns="0" tIns="0" rIns="0" bIns="0" anchor="b" anchorCtr="0">
-            <a:noAutofit/>
-          </a:bodyPr>
-          <a:lstStyle/>
-          <a:p>
-            <a:pPr marL="0" marR="0" lvl="0" indent="0" algn="l" rtl="0">
-              <a:spcBef>
-                <a:spcPts val="0"/>
-              </a:spcBef>
-              <a:spcAft>
-                <a:spcPts val="0"/>
-              </a:spcAft>
-              <a:buClr>
-                <a:srgbClr val="C0392B"/>
-              </a:buClr>
-              <a:buSzPts val="1800"/>
-              <a:buFont typeface="Calibri"/>
-              <a:buNone/>
-            </a:pPr>
-            <a:r>
-              <a:rPr lang="en-US" sz="1800" b="1">
-                <a:solidFill>
-                  <a:srgbClr val="E67E22"/>
-                </a:solidFill>
-                <a:latin typeface="Calibri"/>
-                <a:ea typeface="Calibri"/>
-                <a:cs typeface="Calibri"/>
-                <a:sym typeface="Calibri"/>
-              </a:rPr>
-              <a:t>– de 18 ans &amp; 65 ans et +</a:t>
-            </a:r>
-            <a:endParaRPr sz="1800">
-              <a:solidFill>
-                <a:srgbClr val="E67E22"/>
-              </a:solidFill>
-              <a:latin typeface="Calibri"/>
-              <a:ea typeface="Calibri"/>
-              <a:cs typeface="Calibri"/>
-              <a:sym typeface="Calibri"/>
-            </a:endParaRPr>
-          </a:p>
-        </p:txBody>
-      </p:sp>
-      <p:sp>
-        <p:nvSpPr>
-          <p:cNvPr id="246" name="Google Shape;246;p9"/>
-          <p:cNvSpPr/>
-          <p:nvPr/>
-        </p:nvSpPr>
-        <p:spPr>
-          <a:xfrm>
-            <a:off x="934638" y="1259320"/>
-            <a:ext cx="3167100" cy="237600"/>
-          </a:xfrm>
-          <a:prstGeom prst="rect">
-            <a:avLst/>
-          </a:prstGeom>
-          <a:noFill/>
-          <a:ln>
-            <a:noFill/>
-          </a:ln>
-        </p:spPr>
-        <p:txBody>
-          <a:bodyPr spcFirstLastPara="1" wrap="square" lIns="0" tIns="0" rIns="0" bIns="0" anchor="t" anchorCtr="0">
-            <a:noAutofit/>
-          </a:bodyPr>
-          <a:lstStyle/>
-          <a:p>
-            <a:pPr marL="0" marR="0" lvl="0" indent="0" algn="l" rtl="0">
-              <a:spcBef>
-                <a:spcPts val="0"/>
-              </a:spcBef>
-              <a:spcAft>
-                <a:spcPts val="0"/>
-              </a:spcAft>
-              <a:buClr>
-                <a:srgbClr val="0D1B2A"/>
-              </a:buClr>
-              <a:buSzPts val="1100"/>
-              <a:buFont typeface="Calibri"/>
-              <a:buNone/>
-            </a:pPr>
-            <a:r>
-              <a:rPr lang="en-US" sz="1100">
-                <a:solidFill>
-                  <a:srgbClr val="0D1B2A"/>
-                </a:solidFill>
-                <a:latin typeface="Calibri"/>
-                <a:ea typeface="Calibri"/>
-                <a:cs typeface="Calibri"/>
-                <a:sym typeface="Calibri"/>
-              </a:rPr>
-              <a:t>Tranche d’âge la plus à risque d’accident grave</a:t>
-            </a:r>
-            <a:endParaRPr sz="1100">
-              <a:solidFill>
-                <a:schemeClr val="dk1"/>
-              </a:solidFill>
-              <a:latin typeface="Calibri"/>
-              <a:ea typeface="Calibri"/>
-              <a:cs typeface="Calibri"/>
-              <a:sym typeface="Calibri"/>
-            </a:endParaRPr>
-          </a:p>
-        </p:txBody>
-      </p:sp>
-      <p:sp>
-        <p:nvSpPr>
-          <p:cNvPr id="247" name="Google Shape;247;p9"/>
-          <p:cNvSpPr/>
-          <p:nvPr/>
-        </p:nvSpPr>
-        <p:spPr>
-          <a:xfrm>
-            <a:off x="6035475" y="769774"/>
-            <a:ext cx="1780200" cy="1014000"/>
-          </a:xfrm>
-          <a:prstGeom prst="rect">
-            <a:avLst/>
-          </a:prstGeom>
-          <a:solidFill>
-            <a:srgbClr val="FFFFFF"/>
-          </a:solidFill>
-          <a:ln w="12700" cap="flat" cmpd="sng">
-            <a:solidFill>
-              <a:srgbClr val="FFFFFF"/>
-            </a:solidFill>
-            <a:prstDash val="solid"/>
-            <a:round/>
-            <a:headEnd type="none" w="sm" len="sm"/>
-            <a:tailEnd type="none" w="sm" len="sm"/>
-          </a:ln>
-          <a:effectLst>
-            <a:outerShdw blurRad="101600" dist="38100" dir="8100000" algn="bl" rotWithShape="0">
-              <a:srgbClr val="000000">
-                <a:alpha val="12156"/>
-              </a:srgbClr>
-            </a:outerShdw>
-          </a:effectLst>
-        </p:spPr>
-        <p:txBody>
-          <a:bodyPr spcFirstLastPara="1" wrap="square" lIns="91425" tIns="91425" rIns="91425" bIns="91425" anchor="ctr" anchorCtr="0">
-            <a:noAutofit/>
-          </a:bodyPr>
-          <a:lstStyle/>
-          <a:p>
-            <a:pPr marL="0" lvl="0" indent="0" algn="l" rtl="0">
-              <a:spcBef>
-                <a:spcPts val="0"/>
-              </a:spcBef>
-              <a:spcAft>
-                <a:spcPts val="0"/>
-              </a:spcAft>
-              <a:buNone/>
-            </a:pPr>
-            <a:endParaRPr/>
-          </a:p>
-        </p:txBody>
-      </p:sp>
-      <p:sp>
-        <p:nvSpPr>
-          <p:cNvPr id="248" name="Google Shape;248;p9"/>
-          <p:cNvSpPr/>
-          <p:nvPr/>
-        </p:nvSpPr>
-        <p:spPr>
-          <a:xfrm>
-            <a:off x="5976122" y="782975"/>
-            <a:ext cx="63900" cy="1000800"/>
-          </a:xfrm>
-          <a:prstGeom prst="rect">
-            <a:avLst/>
-          </a:prstGeom>
-          <a:solidFill>
-            <a:srgbClr val="C0392B"/>
-          </a:solidFill>
-          <a:ln w="12700" cap="flat" cmpd="sng">
-            <a:solidFill>
-              <a:srgbClr val="C0392B"/>
-            </a:solidFill>
-            <a:prstDash val="solid"/>
-            <a:round/>
-            <a:headEnd type="none" w="sm" len="sm"/>
-            <a:tailEnd type="none" w="sm" len="sm"/>
-          </a:ln>
-        </p:spPr>
-        <p:txBody>
-          <a:bodyPr spcFirstLastPara="1" wrap="square" lIns="91425" tIns="91425" rIns="91425" bIns="91425" anchor="ctr" anchorCtr="0">
-            <a:noAutofit/>
-          </a:bodyPr>
-          <a:lstStyle/>
-          <a:p>
-            <a:pPr marL="0" lvl="0" indent="0" algn="l" rtl="0">
-              <a:spcBef>
-                <a:spcPts val="0"/>
-              </a:spcBef>
-              <a:spcAft>
-                <a:spcPts val="0"/>
-              </a:spcAft>
-              <a:buNone/>
-            </a:pPr>
-            <a:endParaRPr/>
-          </a:p>
-        </p:txBody>
-      </p:sp>
-      <p:sp>
-        <p:nvSpPr>
-          <p:cNvPr id="249" name="Google Shape;249;p9"/>
-          <p:cNvSpPr/>
-          <p:nvPr/>
-        </p:nvSpPr>
-        <p:spPr>
-          <a:xfrm>
-            <a:off x="6172650" y="1257480"/>
-            <a:ext cx="1553100" cy="502800"/>
-          </a:xfrm>
-          <a:prstGeom prst="rect">
-            <a:avLst/>
-          </a:prstGeom>
-          <a:noFill/>
-          <a:ln>
-            <a:noFill/>
-          </a:ln>
-        </p:spPr>
-        <p:txBody>
-          <a:bodyPr spcFirstLastPara="1" wrap="square" lIns="0" tIns="0" rIns="0" bIns="0" anchor="t" anchorCtr="0">
-            <a:noAutofit/>
-          </a:bodyPr>
-          <a:lstStyle/>
-          <a:p>
-            <a:pPr marL="0" marR="0" lvl="0" indent="0" algn="l" rtl="0">
-              <a:spcBef>
-                <a:spcPts val="0"/>
-              </a:spcBef>
-              <a:spcAft>
-                <a:spcPts val="0"/>
-              </a:spcAft>
-              <a:buClr>
-                <a:srgbClr val="0D1B2A"/>
-              </a:buClr>
-              <a:buSzPts val="1100"/>
-              <a:buFont typeface="Calibri"/>
-              <a:buNone/>
-            </a:pPr>
-            <a:r>
-              <a:rPr lang="en-US" sz="1100">
-                <a:solidFill>
-                  <a:srgbClr val="0D1B2A"/>
-                </a:solidFill>
-                <a:latin typeface="Calibri"/>
-                <a:ea typeface="Calibri"/>
-                <a:cs typeface="Calibri"/>
-                <a:sym typeface="Calibri"/>
-              </a:rPr>
-              <a:t>de risque pour les hommes d’avoir un accident + grave que les femmes</a:t>
-            </a:r>
-            <a:endParaRPr sz="1100">
-              <a:solidFill>
-                <a:schemeClr val="dk1"/>
-              </a:solidFill>
-              <a:latin typeface="Calibri"/>
-              <a:ea typeface="Calibri"/>
-              <a:cs typeface="Calibri"/>
-              <a:sym typeface="Calibri"/>
-            </a:endParaRPr>
-          </a:p>
-        </p:txBody>
-      </p:sp>
-      <p:sp>
-        <p:nvSpPr>
-          <p:cNvPr id="250" name="Google Shape;250;p9"/>
-          <p:cNvSpPr/>
-          <p:nvPr/>
-        </p:nvSpPr>
-        <p:spPr>
-          <a:xfrm>
-            <a:off x="6225000" y="868320"/>
-            <a:ext cx="938400" cy="350400"/>
-          </a:xfrm>
-          <a:prstGeom prst="rect">
-            <a:avLst/>
-          </a:prstGeom>
-          <a:noFill/>
-          <a:ln>
-            <a:noFill/>
-          </a:ln>
-        </p:spPr>
-        <p:txBody>
-          <a:bodyPr spcFirstLastPara="1" wrap="square" lIns="0" tIns="0" rIns="0" bIns="0" anchor="ctr" anchorCtr="0">
-            <a:noAutofit/>
-          </a:bodyPr>
-          <a:lstStyle/>
-          <a:p>
-            <a:pPr marL="0" marR="0" lvl="0" indent="0" algn="l" rtl="0">
-              <a:spcBef>
-                <a:spcPts val="0"/>
-              </a:spcBef>
-              <a:spcAft>
-                <a:spcPts val="0"/>
-              </a:spcAft>
-              <a:buClr>
-                <a:srgbClr val="C0392B"/>
-              </a:buClr>
-              <a:buSzPts val="2400"/>
-              <a:buFont typeface="Calibri"/>
-              <a:buNone/>
-            </a:pPr>
-            <a:r>
-              <a:rPr lang="en-US" sz="2400" b="1">
-                <a:solidFill>
-                  <a:srgbClr val="C0392B"/>
-                </a:solidFill>
-                <a:latin typeface="Calibri"/>
-                <a:ea typeface="Calibri"/>
-                <a:cs typeface="Calibri"/>
-                <a:sym typeface="Calibri"/>
-              </a:rPr>
-              <a:t>+ 45%</a:t>
-            </a:r>
-            <a:endParaRPr sz="2400">
-              <a:solidFill>
-                <a:schemeClr val="dk1"/>
-              </a:solidFill>
-              <a:latin typeface="Calibri"/>
-              <a:ea typeface="Calibri"/>
-              <a:cs typeface="Calibri"/>
-              <a:sym typeface="Calibri"/>
-            </a:endParaRPr>
-          </a:p>
-        </p:txBody>
-      </p:sp>
-      <p:cxnSp>
-        <p:nvCxnSpPr>
-          <p:cNvPr id="251" name="Google Shape;251;p9"/>
-          <p:cNvCxnSpPr>
-            <a:endCxn id="241" idx="0"/>
-          </p:cNvCxnSpPr>
-          <p:nvPr/>
-        </p:nvCxnSpPr>
-        <p:spPr>
-          <a:xfrm flipH="1">
-            <a:off x="4571970" y="639946"/>
-            <a:ext cx="20700" cy="3776100"/>
-          </a:xfrm>
-          <a:prstGeom prst="straightConnector1">
-            <a:avLst/>
-          </a:prstGeom>
-          <a:noFill/>
-          <a:ln w="19050" cap="flat" cmpd="sng">
-            <a:solidFill>
-              <a:srgbClr val="C0392B"/>
-            </a:solidFill>
-            <a:prstDash val="dot"/>
-            <a:round/>
-            <a:headEnd type="none" w="med" len="med"/>
-            <a:tailEnd type="none" w="med" len="med"/>
-          </a:ln>
-        </p:spPr>
-      </p:cxnSp>
-      <p:pic>
-        <p:nvPicPr>
-          <p:cNvPr id="252" name="Google Shape;252;p9"/>
-          <p:cNvPicPr preferRelativeResize="0"/>
-          <p:nvPr/>
-        </p:nvPicPr>
-        <p:blipFill>
-          <a:blip r:embed="rId3">
-            <a:alphaModFix/>
-          </a:blip>
-          <a:stretch>
-            <a:fillRect/>
-          </a:stretch>
-        </p:blipFill>
-        <p:spPr>
-          <a:xfrm>
-            <a:off x="950875" y="1973037"/>
-            <a:ext cx="2646604" cy="2056050"/>
-          </a:xfrm>
-          <a:prstGeom prst="rect">
-            <a:avLst/>
-          </a:prstGeom>
-          <a:noFill/>
-          <a:ln>
-            <a:noFill/>
-          </a:ln>
-        </p:spPr>
-      </p:pic>
-      <p:pic>
-        <p:nvPicPr>
-          <p:cNvPr id="253" name="Google Shape;253;p9"/>
-          <p:cNvPicPr preferRelativeResize="0"/>
-          <p:nvPr/>
-        </p:nvPicPr>
-        <p:blipFill>
-          <a:blip r:embed="rId4">
-            <a:alphaModFix/>
-          </a:blip>
-          <a:stretch>
-            <a:fillRect/>
-          </a:stretch>
-        </p:blipFill>
-        <p:spPr>
-          <a:xfrm>
-            <a:off x="5859999" y="2061381"/>
-            <a:ext cx="2026025" cy="1923368"/>
-          </a:xfrm>
-          <a:prstGeom prst="rect">
-            <a:avLst/>
-          </a:prstGeom>
-          <a:noFill/>
-          <a:ln>
-            <a:noFill/>
-          </a:ln>
-        </p:spPr>
-      </p:pic>
     </p:spTree>
   </p:cSld>
   <p:clrMapOvr>

</xml_diff>